<commit_message>
Fixed a problem with the presentation.
</commit_message>
<xml_diff>
--- a/Presentation and notes/AUBG_Academic_Progress_Tracker_Progress.pptx
+++ b/Presentation and notes/AUBG_Academic_Progress_Tracker_Progress.pptx
@@ -4,6 +4,9 @@
   <p:sldMasterIdLst>
     <p:sldMasterId id="2147483648" r:id="rId1"/>
   </p:sldMasterIdLst>
+  <p:notesMasterIdLst>
+    <p:notesMasterId r:id="rId12"/>
+  </p:notesMasterIdLst>
   <p:sldIdLst>
     <p:sldId id="256" r:id="rId2"/>
     <p:sldId id="257" r:id="rId3"/>
@@ -16,9 +19,6 @@
     <p:sldId id="264" r:id="rId10"/>
     <p:sldId id="265" r:id="rId11"/>
   </p:sldIdLst>
-  <p:notesMasterIdLst>
-    <p:notesMasterId r:id="rId12"/>
-  </p:notesMasterIdLst>
   <p:sldSz cx="12192000" cy="6858000"/>
   <p:notesSz cx="6858000" cy="12192000"/>
   <p:defaultTextStyle>
@@ -113,6 +113,11 @@
       </a:defRPr>
     </a:lvl9pPr>
   </p:defaultTextStyle>
+  <p:extLst>
+    <p:ext uri="{EFAFB233-063F-42B5-8137-9DF3F51BA10A}">
+      <p15:sldGuideLst xmlns:p15="http://schemas.microsoft.com/office/powerpoint/2012/main"/>
+    </p:ext>
+  </p:extLst>
 </p:presentation>
 </file>
 
@@ -138,234 +143,10 @@
           <a:chExt cx="0" cy="0"/>
         </a:xfrm>
       </p:grpSpPr>
-      <p:sp>
-        <p:nvSpPr>
-          <p:cNvPr id="2" name="Header Placeholder 1"/>
-          <p:cNvSpPr>
-            <a:spLocks noGrp="1"/>
-          </p:cNvSpPr>
-          <p:nvPr>
-            <p:ph type="hdr" sz="quarter"/>
-          </p:nvPr>
-        </p:nvSpPr>
-        <p:spPr>
-          <a:xfrm>
-            <a:off x="0" y="0"/>
-            <a:ext cx="2971800" cy="458788"/>
-          </a:xfrm>
-          <a:prstGeom prst="rect">
-            <a:avLst/>
-          </a:prstGeom>
-        </p:spPr>
-        <p:txBody>
-          <a:bodyPr vert="horz" lIns="91440" tIns="45720" rIns="91440" bIns="45720" rtlCol="0"/>
-          <a:lstStyle>
-            <a:lvl1pPr algn="l">
-              <a:defRPr sz="1200"/>
-            </a:lvl1pPr>
-          </a:lstStyle>
-          <a:p>
-            <a:endParaRPr lang="en-US"/>
-          </a:p>
-        </p:txBody>
-      </p:sp>
-      <p:sp>
-        <p:nvSpPr>
-          <p:cNvPr id="3" name="Date Placeholder 2"/>
-          <p:cNvSpPr>
-            <a:spLocks noGrp="1"/>
-          </p:cNvSpPr>
-          <p:nvPr>
-            <p:ph type="dt" idx="1"/>
-          </p:nvPr>
-        </p:nvSpPr>
-        <p:spPr>
-          <a:xfrm>
-            <a:off x="3884613" y="0"/>
-            <a:ext cx="2971800" cy="458788"/>
-          </a:xfrm>
-          <a:prstGeom prst="rect">
-            <a:avLst/>
-          </a:prstGeom>
-        </p:spPr>
-        <p:txBody>
-          <a:bodyPr vert="horz" lIns="91440" tIns="45720" rIns="91440" bIns="45720" rtlCol="0"/>
-          <a:lstStyle>
-            <a:lvl1pPr algn="r">
-              <a:defRPr sz="1200"/>
-            </a:lvl1pPr>
-          </a:lstStyle>
-          <a:p>
-            <a:fld id="{5282F153-3F37-0F45-9E97-73ACFA13230C}" type="datetimeFigureOut">
-              <a:rPr lang="en-US"/>
-              <a:t>7/23/19</a:t>
-            </a:fld>
-            <a:endParaRPr lang="en-US"/>
-          </a:p>
-        </p:txBody>
-      </p:sp>
-      <p:sp>
-        <p:nvSpPr>
-          <p:cNvPr id="4" name="Slide Image Placeholder 3"/>
-          <p:cNvSpPr>
-            <a:spLocks noGrp="1" noRot="1" noChangeAspect="1"/>
-          </p:cNvSpPr>
-          <p:nvPr>
-            <p:ph type="sldImg" idx="2"/>
-          </p:nvPr>
-        </p:nvSpPr>
-        <p:spPr>
-          <a:xfrm>
-            <a:off x="685800" y="1143000"/>
-            <a:ext cx="5486400" cy="3086100"/>
-          </a:xfrm>
-          <a:prstGeom prst="rect">
-            <a:avLst/>
-          </a:prstGeom>
-          <a:noFill/>
-          <a:ln w="12700">
-            <a:solidFill>
-              <a:prstClr val="black"/>
-            </a:solidFill>
-          </a:ln>
-        </p:spPr>
-        <p:txBody>
-          <a:bodyPr vert="horz" lIns="91440" tIns="45720" rIns="91440" bIns="45720" rtlCol="0" anchor="ctr"/>
-          <a:lstStyle/>
-          <a:p>
-            <a:endParaRPr lang="en-US"/>
-          </a:p>
-        </p:txBody>
-      </p:sp>
-      <p:sp>
-        <p:nvSpPr>
-          <p:cNvPr id="5" name="Notes Placeholder 4"/>
-          <p:cNvSpPr>
-            <a:spLocks noGrp="1"/>
-          </p:cNvSpPr>
-          <p:nvPr>
-            <p:ph type="body" sz="quarter" idx="3"/>
-          </p:nvPr>
-        </p:nvSpPr>
-        <p:spPr>
-          <a:xfrm>
-            <a:off x="685800" y="4400550"/>
-            <a:ext cx="5486400" cy="3600450"/>
-          </a:xfrm>
-          <a:prstGeom prst="rect">
-            <a:avLst/>
-          </a:prstGeom>
-        </p:spPr>
-        <p:txBody>
-          <a:bodyPr vert="horz" lIns="91440" tIns="45720" rIns="91440" bIns="45720" rtlCol="0"/>
-          <a:lstStyle/>
-          <a:p>
-            <a:pPr lvl="0"/>
-            <a:r>
-              <a:rPr lang="en-US"/>
-              <a:t>Click to edit Master text styles</a:t>
-            </a:r>
-          </a:p>
-          <a:p>
-            <a:pPr lvl="1"/>
-            <a:r>
-              <a:rPr lang="en-US"/>
-              <a:t>Second level</a:t>
-            </a:r>
-          </a:p>
-          <a:p>
-            <a:pPr lvl="2"/>
-            <a:r>
-              <a:rPr lang="en-US"/>
-              <a:t>Third level</a:t>
-            </a:r>
-          </a:p>
-          <a:p>
-            <a:pPr lvl="3"/>
-            <a:r>
-              <a:rPr lang="en-US"/>
-              <a:t>Fourth level</a:t>
-            </a:r>
-          </a:p>
-          <a:p>
-            <a:pPr lvl="4"/>
-            <a:r>
-              <a:rPr lang="en-US"/>
-              <a:t>Fifth level</a:t>
-            </a:r>
-          </a:p>
-        </p:txBody>
-      </p:sp>
-      <p:sp>
-        <p:nvSpPr>
-          <p:cNvPr id="6" name="Footer Placeholder 5"/>
-          <p:cNvSpPr>
-            <a:spLocks noGrp="1"/>
-          </p:cNvSpPr>
-          <p:nvPr>
-            <p:ph type="ftr" sz="quarter" idx="4"/>
-          </p:nvPr>
-        </p:nvSpPr>
-        <p:spPr>
-          <a:xfrm>
-            <a:off x="0" y="8685213"/>
-            <a:ext cx="2971800" cy="458787"/>
-          </a:xfrm>
-          <a:prstGeom prst="rect">
-            <a:avLst/>
-          </a:prstGeom>
-        </p:spPr>
-        <p:txBody>
-          <a:bodyPr vert="horz" lIns="91440" tIns="45720" rIns="91440" bIns="45720" rtlCol="0" anchor="b"/>
-          <a:lstStyle>
-            <a:lvl1pPr algn="l">
-              <a:defRPr sz="1200"/>
-            </a:lvl1pPr>
-          </a:lstStyle>
-          <a:p>
-            <a:endParaRPr lang="en-US"/>
-          </a:p>
-        </p:txBody>
-      </p:sp>
-      <p:sp>
-        <p:nvSpPr>
-          <p:cNvPr id="7" name="Slide Number Placeholder 6"/>
-          <p:cNvSpPr>
-            <a:spLocks noGrp="1"/>
-          </p:cNvSpPr>
-          <p:nvPr>
-            <p:ph type="sldNum" sz="quarter" idx="5"/>
-          </p:nvPr>
-        </p:nvSpPr>
-        <p:spPr>
-          <a:xfrm>
-            <a:off x="3884613" y="8685213"/>
-            <a:ext cx="2971800" cy="458787"/>
-          </a:xfrm>
-          <a:prstGeom prst="rect">
-            <a:avLst/>
-          </a:prstGeom>
-        </p:spPr>
-        <p:txBody>
-          <a:bodyPr vert="horz" lIns="91440" tIns="45720" rIns="91440" bIns="45720" rtlCol="0" anchor="b"/>
-          <a:lstStyle>
-            <a:lvl1pPr algn="r">
-              <a:defRPr sz="1200"/>
-            </a:lvl1pPr>
-          </a:lstStyle>
-          <a:p>
-            <a:fld id="{CE5E9CC1-C706-0F49-92D6-E571CC5EEA8F}" type="slidenum">
-              <a:rPr lang="en-US"/>
-              <a:t>‹#›</a:t>
-            </a:fld>
-            <a:endParaRPr lang="en-US"/>
-          </a:p>
-        </p:txBody>
-      </p:sp>
     </p:spTree>
     <p:extLst>
       <p:ext uri="{BB962C8B-B14F-4D97-AF65-F5344CB8AC3E}">
-        <p14:creationId xmlns:p14="http://schemas.microsoft.com/office/powerpoint/2010/main" val="1024086991"/>
+        <p14:creationId xmlns:p14="http://schemas.microsoft.com/office/powerpoint/2010/main" val="4049830607"/>
       </p:ext>
     </p:extLst>
   </p:cSld>
@@ -513,7 +294,6 @@
               <a:rPr lang="en-US" dirty="0"/>
               <a:t>Hello. This is a short progress presentation of my senior project, the AUBG Academic Progress Tracker. The project started as a simple GPA calculator, but it has developed into a full Blazor application with persistent storage, course and semester management, academic statistics, and now a much stronger algorithmic component.</a:t>
             </a:r>
-            <a:endParaRPr lang="en-US" dirty="0"/>
           </a:p>
         </p:txBody>
       </p:sp>
@@ -601,7 +381,6 @@
               <a:rPr lang="en-US" dirty="0"/>
               <a:t>The core application is now working and the algorithmic direction is much stronger. Two substantial approaches are implemented: backtracking with pruning, and dynamic programming through memoization. The next major stage will add the third distinct algorithm through a prerequisite graph and topological sort, followed by unit testing, error handling, and final UI and thesis polish.</a:t>
             </a:r>
-            <a:endParaRPr lang="en-US" dirty="0"/>
           </a:p>
         </p:txBody>
       </p:sp>
@@ -689,7 +468,6 @@
               <a:rPr lang="en-US" dirty="0"/>
               <a:t>The goal is not just to display grades. The application combines three ideas: tracking the academic record, calculating the student's current status, and planning future outcomes. It is designed as a local personal tool, so the main focus is software structure, reliable calculations, persistence, and algorithmic decision support.</a:t>
             </a:r>
-            <a:endParaRPr lang="en-US" dirty="0"/>
           </a:p>
         </p:txBody>
       </p:sp>
@@ -777,7 +555,6 @@
               <a:rPr lang="en-US" dirty="0"/>
               <a:t>The project uses a layered architecture. Razor components handle presentation. Services contain application rules and calculations. Entity Framework Core provides the data-access layer, and SQLite stores the persistent data locally. This separation is important because the more advanced GPA algorithms can be developed and tested independently from the user interface.</a:t>
             </a:r>
-            <a:endParaRPr lang="en-US" dirty="0"/>
           </a:p>
         </p:txBody>
       </p:sp>
@@ -865,7 +642,6 @@
               <a:rPr lang="en-US" dirty="0"/>
               <a:t>The data model currently has two persistent entities. A semester can contain many courses, and each course belongs to one semester through SemesterId. SQLite replaced the original temporary list, so data now survives application restarts. Entity Framework Core migrations manage the schema, while the local database file itself is excluded from Git.</a:t>
             </a:r>
-            <a:endParaRPr lang="en-US" dirty="0"/>
           </a:p>
         </p:txBody>
       </p:sp>
@@ -953,7 +729,6 @@
               <a:rPr lang="en-US" dirty="0"/>
               <a:t>At this point the application has the complete core workflow. Courses support full CRUD operations, semesters are stored as real entities, the dashboard shows cumulative GPA and credit statistics, and semester GPA is calculated from related courses. I also added two planning features: the manual What-if Calculator and the automatic Target GPA Solver.</a:t>
             </a:r>
-            <a:endParaRPr lang="en-US" dirty="0"/>
           </a:p>
         </p:txBody>
       </p:sp>
@@ -1041,7 +816,6 @@
               <a:rPr lang="en-US" dirty="0"/>
               <a:t>The What-if Calculator was the first planning feature. It combines the real academic record with temporary future courses and calculates a projected GPA, but the hypothetical courses are never saved. This was a useful design step, although algorithmically it still used the same weighted-average calculation as the dashboard. That led to the next feature.</a:t>
             </a:r>
-            <a:endParaRPr lang="en-US" dirty="0"/>
           </a:p>
         </p:txBody>
       </p:sp>
@@ -1129,7 +903,6 @@
               <a:rPr lang="en-US" dirty="0"/>
               <a:t>The Target GPA Solver reverses the What-if problem. The user gives a target GPA and a list of remaining courses, but does not enter future grades. The program has to search for grades that can achieve the target. Because many combinations may be valid, this becomes a combinatorial search problem rather than a single weighted-average formula.</a:t>
             </a:r>
-            <a:endParaRPr lang="en-US" dirty="0"/>
           </a:p>
         </p:txBody>
       </p:sp>
@@ -1217,7 +990,6 @@
               <a:rPr lang="en-US" dirty="0"/>
               <a:t>The first major algorithm is recursive backtracking. Every level represents a remaining course and every branch represents a possible grade. In the worst case this grows exponentially, O of g to the n. To reduce the search, I added pruning. Impossible branches are cut when even all A grades cannot reach the target, and easy branches finish early when all D grades are already enough.</a:t>
             </a:r>
-            <a:endParaRPr lang="en-US" dirty="0"/>
           </a:p>
         </p:txBody>
       </p:sp>
@@ -1305,7 +1077,6 @@
               <a:rPr lang="en-US" dirty="0"/>
               <a:t>Pruning helped, but large reachable searches were still slow because different grade combinations could lead to the same remaining problem. The second algorithmic approach is dynamic programming through memoization. A state is defined by the current course index and the points still needed. Once a state is solved, its result is cached and reused. This produced the major performance improvement in the solver.</a:t>
             </a:r>
-            <a:endParaRPr lang="en-US" dirty="0"/>
           </a:p>
         </p:txBody>
       </p:sp>
@@ -1383,6 +1154,7 @@
         <a:solidFill>
           <a:srgbClr val="F6F8FB"/>
         </a:solidFill>
+        <a:effectLst/>
       </p:bgPr>
     </p:bg>
     <p:spTree>
@@ -1423,6 +1195,13 @@
             <a:prstDash val="solid"/>
           </a:ln>
         </p:spPr>
+        <p:txBody>
+          <a:bodyPr/>
+          <a:lstStyle/>
+          <a:p>
+            <a:endParaRPr lang="bg-BG"/>
+          </a:p>
+        </p:txBody>
       </p:sp>
       <p:sp>
         <p:nvSpPr>
@@ -1445,7 +1224,7 @@
           <a:bodyPr wrap="square" lIns="0" tIns="0" rIns="0" bIns="0" rtlCol="0" anchor="ctr"/>
           <a:lstStyle/>
           <a:p>
-            <a:pPr indent="0" marL="0">
+            <a:pPr marL="0" indent="0">
               <a:buNone/>
             </a:pPr>
             <a:r>
@@ -1484,7 +1263,7 @@
           <a:bodyPr wrap="square" lIns="0" tIns="0" rIns="0" bIns="0" rtlCol="0" anchor="ctr"/>
           <a:lstStyle/>
           <a:p>
-            <a:pPr algn="r" indent="0" marL="0">
+            <a:pPr marL="0" indent="0" algn="r">
               <a:buNone/>
             </a:pPr>
             <a:r>
@@ -1522,7 +1301,7 @@
           </a:prstGeom>
           <a:extLst>
             <a:ext uri="{C572A759-6A51-4108-AA02-DFA0A04FC94B}">
-              <ma14:wrappingTextBoxFlag xmlns:ma14="http://schemas.microsoft.com/office/mac/drawingml/2011/main" val="0"/>
+              <ma14:wrappingTextBoxFlag xmlns:ma14="http://schemas.microsoft.com/office/mac/drawingml/2011/main" xmlns="" val="0"/>
             </a:ext>
           </a:extLst>
         </p:spPr>
@@ -1543,8 +1322,8 @@
           <a:p>
             <a:pPr algn="r"/>
             <a:fld id="{F7021451-1387-4CA6-816F-3879F97B5CBC}" type="slidenum">
-              <a:rPr b="0" lang="en-US"/>
-              <a:t>1002</a:t>
+              <a:rPr lang="en-US" b="0"/>
+              <a:t>‹#›</a:t>
             </a:fld>
             <a:endParaRPr lang="en-US"/>
           </a:p>
@@ -1561,6 +1340,11 @@
 <file path=ppt/slideMasters/slideMaster1.xml><?xml version="1.0" encoding="utf-8"?>
 <p:sldMaster xmlns:a="http://schemas.openxmlformats.org/drawingml/2006/main" xmlns:r="http://schemas.openxmlformats.org/officeDocument/2006/relationships" xmlns:p="http://schemas.openxmlformats.org/presentationml/2006/main">
   <p:cSld>
+    <p:bg>
+      <p:bgRef idx="1001">
+        <a:schemeClr val="bg1"/>
+      </p:bgRef>
+    </p:bg>
     <p:spTree>
       <p:nvGrpSpPr>
         <p:cNvPr id="1" name=""/>
@@ -1595,7 +1379,7 @@
           </a:prstGeom>
           <a:extLst>
             <a:ext uri="{C572A759-6A51-4108-AA02-DFA0A04FC94B}">
-              <ma14:wrappingTextBoxFlag xmlns:ma14="http://schemas.microsoft.com/office/mac/drawingml/2011/main" val="0"/>
+              <ma14:wrappingTextBoxFlag xmlns:ma14="http://schemas.microsoft.com/office/mac/drawingml/2011/main" xmlns="" val="0"/>
             </a:ext>
           </a:extLst>
         </p:spPr>
@@ -1616,8 +1400,8 @@
           <a:p>
             <a:pPr algn="r"/>
             <a:fld id="{F7021451-1387-4CA6-816F-3879F97B5CBC}" type="slidenum">
-              <a:rPr b="0" lang="en-US"/>
-              <a:t>null</a:t>
+              <a:rPr lang="en-US" b="0"/>
+              <a:t>‹#›</a:t>
             </a:fld>
             <a:endParaRPr lang="en-US"/>
           </a:p>
@@ -1892,6 +1676,7 @@
         <a:solidFill>
           <a:srgbClr val="0B1F33"/>
         </a:solidFill>
+        <a:effectLst/>
       </p:bgPr>
     </p:bg>
     <p:spTree>
@@ -1932,6 +1717,13 @@
             <a:prstDash val="solid"/>
           </a:ln>
         </p:spPr>
+        <p:txBody>
+          <a:bodyPr/>
+          <a:lstStyle/>
+          <a:p>
+            <a:endParaRPr lang="bg-BG"/>
+          </a:p>
+        </p:txBody>
       </p:sp>
       <p:sp>
         <p:nvSpPr>
@@ -1961,6 +1753,13 @@
             <a:prstDash val="solid"/>
           </a:ln>
         </p:spPr>
+        <p:txBody>
+          <a:bodyPr/>
+          <a:lstStyle/>
+          <a:p>
+            <a:endParaRPr lang="bg-BG"/>
+          </a:p>
+        </p:txBody>
       </p:sp>
       <p:sp>
         <p:nvSpPr>
@@ -1990,6 +1789,13 @@
             <a:prstDash val="solid"/>
           </a:ln>
         </p:spPr>
+        <p:txBody>
+          <a:bodyPr/>
+          <a:lstStyle/>
+          <a:p>
+            <a:endParaRPr lang="bg-BG"/>
+          </a:p>
+        </p:txBody>
       </p:sp>
       <p:sp>
         <p:nvSpPr>
@@ -2012,7 +1818,7 @@
           <a:bodyPr wrap="square" lIns="0" tIns="0" rIns="0" bIns="0" rtlCol="0" anchor="ctr"/>
           <a:lstStyle/>
           <a:p>
-            <a:pPr indent="0" marL="0">
+            <a:pPr marL="0" indent="0">
               <a:buNone/>
             </a:pPr>
             <a:r>
@@ -2029,7 +1835,7 @@
             <a:endParaRPr lang="en-US" sz="3000" dirty="0"/>
           </a:p>
           <a:p>
-            <a:pPr indent="0" marL="0">
+            <a:pPr marL="0" indent="0">
               <a:buNone/>
             </a:pPr>
             <a:r>
@@ -2068,7 +1874,7 @@
           <a:bodyPr wrap="square" lIns="0" tIns="0" rIns="0" bIns="0" rtlCol="0" anchor="ctr"/>
           <a:lstStyle/>
           <a:p>
-            <a:pPr indent="0" marL="0">
+            <a:pPr marL="0" indent="0">
               <a:buNone/>
             </a:pPr>
             <a:r>
@@ -2105,6 +1911,13 @@
             <a:prstDash val="solid"/>
           </a:ln>
         </p:spPr>
+        <p:txBody>
+          <a:bodyPr/>
+          <a:lstStyle/>
+          <a:p>
+            <a:endParaRPr lang="bg-BG"/>
+          </a:p>
+        </p:txBody>
       </p:sp>
       <p:sp>
         <p:nvSpPr>
@@ -2127,7 +1940,7 @@
           <a:bodyPr wrap="square" lIns="0" tIns="0" rIns="0" bIns="0" rtlCol="0" anchor="ctr"/>
           <a:lstStyle/>
           <a:p>
-            <a:pPr indent="0" marL="0">
+            <a:pPr marL="0" indent="0">
               <a:buNone/>
             </a:pPr>
             <a:r>
@@ -2163,7 +1976,7 @@
           <a:bodyPr wrap="square" lIns="0" tIns="0" rIns="0" bIns="0" rtlCol="0" anchor="ctr"/>
           <a:lstStyle/>
           <a:p>
-            <a:pPr indent="0" marL="0">
+            <a:pPr marL="0" indent="0">
               <a:buNone/>
             </a:pPr>
             <a:r>
@@ -2205,7 +2018,7 @@
           <a:bodyPr wrap="square" lIns="635" tIns="635" rIns="635" bIns="635" rtlCol="0" anchor="ctr"/>
           <a:lstStyle/>
           <a:p>
-            <a:pPr algn="ctr" indent="0" marL="0">
+            <a:pPr marL="0" indent="0" algn="ctr">
               <a:buNone/>
             </a:pPr>
             <a:r>
@@ -2266,7 +2079,7 @@
           <a:bodyPr wrap="square" lIns="0" tIns="0" rIns="0" bIns="0" rtlCol="0" anchor="ctr"/>
           <a:lstStyle/>
           <a:p>
-            <a:pPr indent="0" marL="0">
+            <a:pPr marL="0" indent="0">
               <a:buNone/>
             </a:pPr>
             <a:r>
@@ -2305,7 +2118,7 @@
           <a:bodyPr wrap="square" lIns="0" tIns="0" rIns="0" bIns="0" rtlCol="0" anchor="ctr"/>
           <a:lstStyle/>
           <a:p>
-            <a:pPr indent="0" marL="0">
+            <a:pPr marL="0" indent="0">
               <a:buNone/>
             </a:pPr>
             <a:r>
@@ -2345,6 +2158,13 @@
             <a:prstDash val="solid"/>
           </a:ln>
         </p:spPr>
+        <p:txBody>
+          <a:bodyPr/>
+          <a:lstStyle/>
+          <a:p>
+            <a:endParaRPr lang="bg-BG"/>
+          </a:p>
+        </p:txBody>
       </p:sp>
       <p:sp>
         <p:nvSpPr>
@@ -2370,6 +2190,13 @@
             <a:prstDash val="solid"/>
           </a:ln>
         </p:spPr>
+        <p:txBody>
+          <a:bodyPr/>
+          <a:lstStyle/>
+          <a:p>
+            <a:endParaRPr lang="bg-BG"/>
+          </a:p>
+        </p:txBody>
       </p:sp>
       <p:sp>
         <p:nvSpPr>
@@ -2392,7 +2219,7 @@
           <a:bodyPr wrap="square" lIns="0" tIns="0" rIns="0" bIns="0" rtlCol="0" anchor="ctr"/>
           <a:lstStyle/>
           <a:p>
-            <a:pPr algn="ctr" indent="0" marL="0">
+            <a:pPr marL="0" indent="0" algn="ctr">
               <a:buNone/>
             </a:pPr>
             <a:r>
@@ -2428,7 +2255,7 @@
           <a:bodyPr wrap="square" lIns="0" tIns="0" rIns="0" bIns="0" rtlCol="0" anchor="ctr"/>
           <a:lstStyle/>
           <a:p>
-            <a:pPr algn="ctr" indent="0" marL="0">
+            <a:pPr marL="0" indent="0" algn="ctr">
               <a:buNone/>
             </a:pPr>
             <a:r>
@@ -2464,7 +2291,7 @@
           <a:bodyPr wrap="square" lIns="0" tIns="0" rIns="0" bIns="0" rtlCol="0" anchor="ctr"/>
           <a:lstStyle/>
           <a:p>
-            <a:pPr algn="ctr" indent="0" marL="0">
+            <a:pPr marL="0" indent="0" algn="ctr">
               <a:buNone/>
             </a:pPr>
             <a:r>
@@ -2503,6 +2330,13 @@
             <a:prstDash val="solid"/>
           </a:ln>
         </p:spPr>
+        <p:txBody>
+          <a:bodyPr/>
+          <a:lstStyle/>
+          <a:p>
+            <a:endParaRPr lang="bg-BG"/>
+          </a:p>
+        </p:txBody>
       </p:sp>
       <p:sp>
         <p:nvSpPr>
@@ -2525,7 +2359,7 @@
           <a:bodyPr wrap="square" lIns="0" tIns="0" rIns="0" bIns="0" rtlCol="0" anchor="ctr"/>
           <a:lstStyle/>
           <a:p>
-            <a:pPr algn="ctr" indent="0" marL="0">
+            <a:pPr marL="0" indent="0" algn="ctr">
               <a:buNone/>
             </a:pPr>
             <a:r>
@@ -2561,7 +2395,7 @@
           <a:bodyPr wrap="square" lIns="0" tIns="0" rIns="0" bIns="0" rtlCol="0" anchor="ctr"/>
           <a:lstStyle/>
           <a:p>
-            <a:pPr algn="ctr" indent="0" marL="0">
+            <a:pPr marL="0" indent="0" algn="ctr">
               <a:buNone/>
             </a:pPr>
             <a:r>
@@ -2597,7 +2431,7 @@
           <a:bodyPr wrap="square" lIns="0" tIns="0" rIns="0" bIns="0" rtlCol="0" anchor="ctr"/>
           <a:lstStyle/>
           <a:p>
-            <a:pPr algn="ctr" indent="0" marL="0">
+            <a:pPr marL="0" indent="0" algn="ctr">
               <a:buNone/>
             </a:pPr>
             <a:r>
@@ -2636,6 +2470,13 @@
             <a:prstDash val="solid"/>
           </a:ln>
         </p:spPr>
+        <p:txBody>
+          <a:bodyPr/>
+          <a:lstStyle/>
+          <a:p>
+            <a:endParaRPr lang="bg-BG"/>
+          </a:p>
+        </p:txBody>
       </p:sp>
       <p:sp>
         <p:nvSpPr>
@@ -2658,7 +2499,7 @@
           <a:bodyPr wrap="square" lIns="0" tIns="0" rIns="0" bIns="0" rtlCol="0" anchor="ctr"/>
           <a:lstStyle/>
           <a:p>
-            <a:pPr algn="ctr" indent="0" marL="0">
+            <a:pPr marL="0" indent="0" algn="ctr">
               <a:buNone/>
             </a:pPr>
             <a:r>
@@ -2694,7 +2535,7 @@
           <a:bodyPr wrap="square" lIns="0" tIns="0" rIns="0" bIns="0" rtlCol="0" anchor="ctr"/>
           <a:lstStyle/>
           <a:p>
-            <a:pPr algn="ctr" indent="0" marL="0">
+            <a:pPr marL="0" indent="0" algn="ctr">
               <a:buNone/>
             </a:pPr>
             <a:r>
@@ -2730,7 +2571,7 @@
           <a:bodyPr wrap="square" lIns="0" tIns="0" rIns="0" bIns="0" rtlCol="0" anchor="ctr"/>
           <a:lstStyle/>
           <a:p>
-            <a:pPr algn="ctr" indent="0" marL="0">
+            <a:pPr marL="0" indent="0" algn="ctr">
               <a:buNone/>
             </a:pPr>
             <a:r>
@@ -2769,6 +2610,13 @@
             <a:prstDash val="solid"/>
           </a:ln>
         </p:spPr>
+        <p:txBody>
+          <a:bodyPr/>
+          <a:lstStyle/>
+          <a:p>
+            <a:endParaRPr lang="bg-BG"/>
+          </a:p>
+        </p:txBody>
       </p:sp>
       <p:sp>
         <p:nvSpPr>
@@ -2791,7 +2639,7 @@
           <a:bodyPr wrap="square" lIns="0" tIns="0" rIns="0" bIns="0" rtlCol="0" anchor="ctr"/>
           <a:lstStyle/>
           <a:p>
-            <a:pPr algn="ctr" indent="0" marL="0">
+            <a:pPr marL="0" indent="0" algn="ctr">
               <a:buNone/>
             </a:pPr>
             <a:r>
@@ -2827,7 +2675,7 @@
           <a:bodyPr wrap="square" lIns="0" tIns="0" rIns="0" bIns="0" rtlCol="0" anchor="ctr"/>
           <a:lstStyle/>
           <a:p>
-            <a:pPr algn="ctr" indent="0" marL="0">
+            <a:pPr marL="0" indent="0" algn="ctr">
               <a:buNone/>
             </a:pPr>
             <a:r>
@@ -2863,7 +2711,7 @@
           <a:bodyPr wrap="square" lIns="0" tIns="0" rIns="0" bIns="0" rtlCol="0" anchor="ctr"/>
           <a:lstStyle/>
           <a:p>
-            <a:pPr algn="ctr" indent="0" marL="0">
+            <a:pPr marL="0" indent="0" algn="ctr">
               <a:buNone/>
             </a:pPr>
             <a:r>
@@ -2902,6 +2750,13 @@
             <a:prstDash val="solid"/>
           </a:ln>
         </p:spPr>
+        <p:txBody>
+          <a:bodyPr/>
+          <a:lstStyle/>
+          <a:p>
+            <a:endParaRPr lang="bg-BG"/>
+          </a:p>
+        </p:txBody>
       </p:sp>
       <p:sp>
         <p:nvSpPr>
@@ -2924,7 +2779,7 @@
           <a:bodyPr wrap="square" lIns="0" tIns="0" rIns="0" bIns="0" rtlCol="0" anchor="ctr"/>
           <a:lstStyle/>
           <a:p>
-            <a:pPr algn="ctr" indent="0" marL="0">
+            <a:pPr marL="0" indent="0" algn="ctr">
               <a:buNone/>
             </a:pPr>
             <a:r>
@@ -2960,7 +2815,7 @@
           <a:bodyPr wrap="square" lIns="0" tIns="0" rIns="0" bIns="0" rtlCol="0" anchor="ctr"/>
           <a:lstStyle/>
           <a:p>
-            <a:pPr algn="ctr" indent="0" marL="0">
+            <a:pPr marL="0" indent="0" algn="ctr">
               <a:buNone/>
             </a:pPr>
             <a:r>
@@ -2999,6 +2854,13 @@
             <a:prstDash val="solid"/>
           </a:ln>
         </p:spPr>
+        <p:txBody>
+          <a:bodyPr/>
+          <a:lstStyle/>
+          <a:p>
+            <a:endParaRPr lang="bg-BG"/>
+          </a:p>
+        </p:txBody>
       </p:sp>
       <p:sp>
         <p:nvSpPr>
@@ -3021,7 +2883,7 @@
           <a:bodyPr wrap="square" lIns="0" tIns="0" rIns="0" bIns="0" rtlCol="0" anchor="ctr"/>
           <a:lstStyle/>
           <a:p>
-            <a:pPr indent="0" marL="0">
+            <a:pPr marL="0" indent="0">
               <a:buNone/>
             </a:pPr>
             <a:r>
@@ -3057,7 +2919,7 @@
           <a:bodyPr wrap="square" lIns="0" tIns="0" rIns="0" bIns="0" rtlCol="0" anchor="ctr"/>
           <a:lstStyle/>
           <a:p>
-            <a:pPr indent="0" marL="0">
+            <a:pPr marL="0" indent="0">
               <a:buNone/>
             </a:pPr>
             <a:r>
@@ -3096,6 +2958,13 @@
             <a:prstDash val="solid"/>
           </a:ln>
         </p:spPr>
+        <p:txBody>
+          <a:bodyPr/>
+          <a:lstStyle/>
+          <a:p>
+            <a:endParaRPr lang="bg-BG"/>
+          </a:p>
+        </p:txBody>
       </p:sp>
       <p:sp>
         <p:nvSpPr>
@@ -3118,7 +2987,7 @@
           <a:bodyPr wrap="square" lIns="0" tIns="0" rIns="0" bIns="0" rtlCol="0" anchor="ctr"/>
           <a:lstStyle/>
           <a:p>
-            <a:pPr indent="0" marL="0">
+            <a:pPr marL="0" indent="0">
               <a:buNone/>
             </a:pPr>
             <a:r>
@@ -3154,7 +3023,7 @@
           <a:bodyPr wrap="square" lIns="0" tIns="0" rIns="0" bIns="0" rtlCol="0" anchor="ctr"/>
           <a:lstStyle/>
           <a:p>
-            <a:pPr indent="0" marL="0">
+            <a:pPr marL="0" indent="0">
               <a:buNone/>
             </a:pPr>
             <a:r>
@@ -3190,7 +3059,7 @@
           <a:bodyPr wrap="square" lIns="0" tIns="0" rIns="0" bIns="0" rtlCol="0" anchor="ctr"/>
           <a:lstStyle/>
           <a:p>
-            <a:pPr algn="ctr" indent="0" marL="0">
+            <a:pPr marL="0" indent="0" algn="ctr">
               <a:buNone/>
             </a:pPr>
             <a:r>
@@ -3207,7 +3076,7 @@
       </p:sp>
       <p:sp>
         <p:nvSpPr>
-          <p:cNvPr id="25" name="Slide Number Placeholder 0"/>
+          <p:cNvPr id="31" name="Slide Number Placeholder 0"/>
           <p:cNvSpPr>
             <a:spLocks noGrp="1"/>
           </p:cNvSpPr>
@@ -3225,7 +3094,7 @@
           </a:prstGeom>
           <a:extLst>
             <a:ext uri="{C572A759-6A51-4108-AA02-DFA0A04FC94B}">
-              <ma14:wrappingTextBoxFlag xmlns:ma14="http://schemas.microsoft.com/office/mac/drawingml/2011/main" val="0"/>
+              <ma14:wrappingTextBoxFlag xmlns:ma14="http://schemas.microsoft.com/office/mac/drawingml/2011/main" xmlns="" val="0"/>
             </a:ext>
           </a:extLst>
         </p:spPr>
@@ -3246,7 +3115,7 @@
           <a:p>
             <a:pPr algn="r"/>
             <a:fld id="{F7021451-1387-4CA6-816F-3879F97B5CBC}" type="slidenum">
-              <a:rPr b="0" lang="en-US"/>
+              <a:rPr lang="en-US" b="0"/>
               <a:t>10</a:t>
             </a:fld>
             <a:endParaRPr lang="en-US"/>
@@ -3299,7 +3168,7 @@
           <a:bodyPr wrap="square" lIns="0" tIns="0" rIns="0" bIns="0" rtlCol="0" anchor="ctr"/>
           <a:lstStyle/>
           <a:p>
-            <a:pPr indent="0" marL="0">
+            <a:pPr marL="0" indent="0">
               <a:buNone/>
             </a:pPr>
             <a:r>
@@ -3338,7 +3207,7 @@
           <a:bodyPr wrap="square" lIns="0" tIns="0" rIns="0" bIns="0" rtlCol="0" anchor="ctr"/>
           <a:lstStyle/>
           <a:p>
-            <a:pPr indent="0" marL="0">
+            <a:pPr marL="0" indent="0">
               <a:buNone/>
             </a:pPr>
             <a:r>
@@ -3382,13 +3251,20 @@
             <a:prstDash val="solid"/>
           </a:ln>
           <a:effectLst>
-            <a:outerShdw sx="100000" sy="100000" kx="0" ky="0" algn="bl" rotWithShape="0" blurRad="12700" dist="50800" dir="2700000">
+            <a:outerShdw blurRad="12700" dist="50800" dir="2700000" algn="bl" rotWithShape="0">
               <a:srgbClr val="B8C4D1">
                 <a:alpha val="16000"/>
               </a:srgbClr>
             </a:outerShdw>
           </a:effectLst>
         </p:spPr>
+        <p:txBody>
+          <a:bodyPr/>
+          <a:lstStyle/>
+          <a:p>
+            <a:endParaRPr lang="bg-BG"/>
+          </a:p>
+        </p:txBody>
       </p:sp>
       <p:sp>
         <p:nvSpPr>
@@ -3414,6 +3290,13 @@
             <a:prstDash val="solid"/>
           </a:ln>
         </p:spPr>
+        <p:txBody>
+          <a:bodyPr/>
+          <a:lstStyle/>
+          <a:p>
+            <a:endParaRPr lang="bg-BG"/>
+          </a:p>
+        </p:txBody>
       </p:sp>
       <p:sp>
         <p:nvSpPr>
@@ -3436,7 +3319,7 @@
           <a:bodyPr wrap="square" lIns="0" tIns="0" rIns="0" bIns="0" rtlCol="0" anchor="ctr"/>
           <a:lstStyle/>
           <a:p>
-            <a:pPr indent="0" marL="0">
+            <a:pPr marL="0" indent="0">
               <a:buNone/>
             </a:pPr>
             <a:r>
@@ -3472,7 +3355,7 @@
           <a:bodyPr wrap="square" lIns="254" tIns="254" rIns="254" bIns="254" rtlCol="0" anchor="t"/>
           <a:lstStyle/>
           <a:p>
-            <a:pPr indent="0" marL="0">
+            <a:pPr marL="0" indent="0">
               <a:buNone/>
             </a:pPr>
             <a:r>
@@ -3513,13 +3396,20 @@
             <a:prstDash val="solid"/>
           </a:ln>
           <a:effectLst>
-            <a:outerShdw sx="100000" sy="100000" kx="0" ky="0" algn="bl" rotWithShape="0" blurRad="12700" dist="50800" dir="2700000">
+            <a:outerShdw blurRad="12700" dist="50800" dir="2700000" algn="bl" rotWithShape="0">
               <a:srgbClr val="B8C4D1">
                 <a:alpha val="16000"/>
               </a:srgbClr>
             </a:outerShdw>
           </a:effectLst>
         </p:spPr>
+        <p:txBody>
+          <a:bodyPr/>
+          <a:lstStyle/>
+          <a:p>
+            <a:endParaRPr lang="bg-BG"/>
+          </a:p>
+        </p:txBody>
       </p:sp>
       <p:sp>
         <p:nvSpPr>
@@ -3545,6 +3435,13 @@
             <a:prstDash val="solid"/>
           </a:ln>
         </p:spPr>
+        <p:txBody>
+          <a:bodyPr/>
+          <a:lstStyle/>
+          <a:p>
+            <a:endParaRPr lang="bg-BG"/>
+          </a:p>
+        </p:txBody>
       </p:sp>
       <p:sp>
         <p:nvSpPr>
@@ -3567,7 +3464,7 @@
           <a:bodyPr wrap="square" lIns="0" tIns="0" rIns="0" bIns="0" rtlCol="0" anchor="ctr"/>
           <a:lstStyle/>
           <a:p>
-            <a:pPr indent="0" marL="0">
+            <a:pPr marL="0" indent="0">
               <a:buNone/>
             </a:pPr>
             <a:r>
@@ -3603,7 +3500,7 @@
           <a:bodyPr wrap="square" lIns="254" tIns="254" rIns="254" bIns="254" rtlCol="0" anchor="t"/>
           <a:lstStyle/>
           <a:p>
-            <a:pPr indent="0" marL="0">
+            <a:pPr marL="0" indent="0">
               <a:buNone/>
             </a:pPr>
             <a:r>
@@ -3644,13 +3541,20 @@
             <a:prstDash val="solid"/>
           </a:ln>
           <a:effectLst>
-            <a:outerShdw sx="100000" sy="100000" kx="0" ky="0" algn="bl" rotWithShape="0" blurRad="12700" dist="50800" dir="2700000">
+            <a:outerShdw blurRad="12700" dist="50800" dir="2700000" algn="bl" rotWithShape="0">
               <a:srgbClr val="B8C4D1">
                 <a:alpha val="16000"/>
               </a:srgbClr>
             </a:outerShdw>
           </a:effectLst>
         </p:spPr>
+        <p:txBody>
+          <a:bodyPr/>
+          <a:lstStyle/>
+          <a:p>
+            <a:endParaRPr lang="bg-BG"/>
+          </a:p>
+        </p:txBody>
       </p:sp>
       <p:sp>
         <p:nvSpPr>
@@ -3676,6 +3580,13 @@
             <a:prstDash val="solid"/>
           </a:ln>
         </p:spPr>
+        <p:txBody>
+          <a:bodyPr/>
+          <a:lstStyle/>
+          <a:p>
+            <a:endParaRPr lang="bg-BG"/>
+          </a:p>
+        </p:txBody>
       </p:sp>
       <p:sp>
         <p:nvSpPr>
@@ -3698,7 +3609,7 @@
           <a:bodyPr wrap="square" lIns="0" tIns="0" rIns="0" bIns="0" rtlCol="0" anchor="ctr"/>
           <a:lstStyle/>
           <a:p>
-            <a:pPr indent="0" marL="0">
+            <a:pPr marL="0" indent="0">
               <a:buNone/>
             </a:pPr>
             <a:r>
@@ -3734,7 +3645,7 @@
           <a:bodyPr wrap="square" lIns="254" tIns="254" rIns="254" bIns="254" rtlCol="0" anchor="t"/>
           <a:lstStyle/>
           <a:p>
-            <a:pPr indent="0" marL="0">
+            <a:pPr marL="0" indent="0">
               <a:buNone/>
             </a:pPr>
             <a:r>
@@ -3773,6 +3684,13 @@
             <a:prstDash val="solid"/>
           </a:ln>
         </p:spPr>
+        <p:txBody>
+          <a:bodyPr/>
+          <a:lstStyle/>
+          <a:p>
+            <a:endParaRPr lang="bg-BG"/>
+          </a:p>
+        </p:txBody>
       </p:sp>
       <p:sp>
         <p:nvSpPr>
@@ -3795,7 +3713,7 @@
           <a:bodyPr wrap="square" lIns="0" tIns="0" rIns="0" bIns="0" rtlCol="0" anchor="ctr"/>
           <a:lstStyle/>
           <a:p>
-            <a:pPr indent="0" marL="0">
+            <a:pPr marL="0" indent="0">
               <a:buNone/>
             </a:pPr>
             <a:r>
@@ -3831,7 +3749,7 @@
           <a:bodyPr wrap="square" lIns="0" tIns="0" rIns="0" bIns="0" rtlCol="0" anchor="ctr"/>
           <a:lstStyle/>
           <a:p>
-            <a:pPr indent="0" marL="0">
+            <a:pPr marL="0" indent="0">
               <a:buNone/>
             </a:pPr>
             <a:r>
@@ -3867,7 +3785,7 @@
           <a:bodyPr wrap="square" lIns="254" tIns="254" rIns="254" bIns="254" rtlCol="0" anchor="ctr"/>
           <a:lstStyle/>
           <a:p>
-            <a:pPr indent="0" marL="0">
+            <a:pPr marL="0" indent="0">
               <a:buNone/>
             </a:pPr>
             <a:r>
@@ -3906,6 +3824,13 @@
             <a:prstDash val="solid"/>
           </a:ln>
         </p:spPr>
+        <p:txBody>
+          <a:bodyPr/>
+          <a:lstStyle/>
+          <a:p>
+            <a:endParaRPr lang="bg-BG"/>
+          </a:p>
+        </p:txBody>
       </p:sp>
       <p:sp>
         <p:nvSpPr>
@@ -3928,7 +3853,7 @@
           <a:bodyPr wrap="square" lIns="0" tIns="0" rIns="0" bIns="0" rtlCol="0" anchor="ctr"/>
           <a:lstStyle/>
           <a:p>
-            <a:pPr algn="ctr" indent="0" marL="0">
+            <a:pPr marL="0" indent="0" algn="ctr">
               <a:buNone/>
             </a:pPr>
             <a:r>
@@ -3967,6 +3892,13 @@
             <a:prstDash val="solid"/>
           </a:ln>
         </p:spPr>
+        <p:txBody>
+          <a:bodyPr/>
+          <a:lstStyle/>
+          <a:p>
+            <a:endParaRPr lang="bg-BG"/>
+          </a:p>
+        </p:txBody>
       </p:sp>
       <p:sp>
         <p:nvSpPr>
@@ -3989,7 +3921,7 @@
           <a:bodyPr wrap="square" lIns="0" tIns="0" rIns="0" bIns="0" rtlCol="0" anchor="ctr"/>
           <a:lstStyle/>
           <a:p>
-            <a:pPr algn="ctr" indent="0" marL="0">
+            <a:pPr marL="0" indent="0" algn="ctr">
               <a:buNone/>
             </a:pPr>
             <a:r>
@@ -4028,6 +3960,13 @@
             <a:prstDash val="solid"/>
           </a:ln>
         </p:spPr>
+        <p:txBody>
+          <a:bodyPr/>
+          <a:lstStyle/>
+          <a:p>
+            <a:endParaRPr lang="bg-BG"/>
+          </a:p>
+        </p:txBody>
       </p:sp>
       <p:sp>
         <p:nvSpPr>
@@ -4050,7 +3989,7 @@
           <a:bodyPr wrap="square" lIns="0" tIns="0" rIns="0" bIns="0" rtlCol="0" anchor="ctr"/>
           <a:lstStyle/>
           <a:p>
-            <a:pPr algn="ctr" indent="0" marL="0">
+            <a:pPr marL="0" indent="0" algn="ctr">
               <a:buNone/>
             </a:pPr>
             <a:r>
@@ -4089,6 +4028,13 @@
             <a:prstDash val="solid"/>
           </a:ln>
         </p:spPr>
+        <p:txBody>
+          <a:bodyPr/>
+          <a:lstStyle/>
+          <a:p>
+            <a:endParaRPr lang="bg-BG"/>
+          </a:p>
+        </p:txBody>
       </p:sp>
       <p:sp>
         <p:nvSpPr>
@@ -4111,7 +4057,7 @@
           <a:bodyPr wrap="square" lIns="0" tIns="0" rIns="0" bIns="0" rtlCol="0" anchor="ctr"/>
           <a:lstStyle/>
           <a:p>
-            <a:pPr algn="ctr" indent="0" marL="0">
+            <a:pPr marL="0" indent="0" algn="ctr">
               <a:buNone/>
             </a:pPr>
             <a:r>
@@ -4128,7 +4074,7 @@
       </p:sp>
       <p:sp>
         <p:nvSpPr>
-          <p:cNvPr id="25" name="Slide Number Placeholder 0"/>
+          <p:cNvPr id="28" name="Slide Number Placeholder 0"/>
           <p:cNvSpPr>
             <a:spLocks noGrp="1"/>
           </p:cNvSpPr>
@@ -4146,7 +4092,7 @@
           </a:prstGeom>
           <a:extLst>
             <a:ext uri="{C572A759-6A51-4108-AA02-DFA0A04FC94B}">
-              <ma14:wrappingTextBoxFlag xmlns:ma14="http://schemas.microsoft.com/office/mac/drawingml/2011/main" val="0"/>
+              <ma14:wrappingTextBoxFlag xmlns:ma14="http://schemas.microsoft.com/office/mac/drawingml/2011/main" xmlns="" val="0"/>
             </a:ext>
           </a:extLst>
         </p:spPr>
@@ -4167,7 +4113,7 @@
           <a:p>
             <a:pPr algn="r"/>
             <a:fld id="{F7021451-1387-4CA6-816F-3879F97B5CBC}" type="slidenum">
-              <a:rPr b="0" lang="en-US"/>
+              <a:rPr lang="en-US" b="0"/>
               <a:t>2</a:t>
             </a:fld>
             <a:endParaRPr lang="en-US"/>
@@ -4220,7 +4166,7 @@
           <a:bodyPr wrap="square" lIns="0" tIns="0" rIns="0" bIns="0" rtlCol="0" anchor="ctr"/>
           <a:lstStyle/>
           <a:p>
-            <a:pPr indent="0" marL="0">
+            <a:pPr marL="0" indent="0">
               <a:buNone/>
             </a:pPr>
             <a:r>
@@ -4259,7 +4205,7 @@
           <a:bodyPr wrap="square" lIns="0" tIns="0" rIns="0" bIns="0" rtlCol="0" anchor="ctr"/>
           <a:lstStyle/>
           <a:p>
-            <a:pPr indent="0" marL="0">
+            <a:pPr marL="0" indent="0">
               <a:buNone/>
             </a:pPr>
             <a:r>
@@ -4301,6 +4247,13 @@
             <a:prstDash val="solid"/>
           </a:ln>
         </p:spPr>
+        <p:txBody>
+          <a:bodyPr/>
+          <a:lstStyle/>
+          <a:p>
+            <a:endParaRPr lang="bg-BG"/>
+          </a:p>
+        </p:txBody>
       </p:sp>
       <p:sp>
         <p:nvSpPr>
@@ -4326,6 +4279,13 @@
             <a:prstDash val="solid"/>
           </a:ln>
         </p:spPr>
+        <p:txBody>
+          <a:bodyPr/>
+          <a:lstStyle/>
+          <a:p>
+            <a:endParaRPr lang="bg-BG"/>
+          </a:p>
+        </p:txBody>
       </p:sp>
       <p:sp>
         <p:nvSpPr>
@@ -4348,7 +4308,7 @@
           <a:bodyPr wrap="square" lIns="0" tIns="0" rIns="0" bIns="0" rtlCol="0" anchor="ctr"/>
           <a:lstStyle/>
           <a:p>
-            <a:pPr indent="0" marL="0">
+            <a:pPr marL="0" indent="0">
               <a:buNone/>
             </a:pPr>
             <a:r>
@@ -4384,7 +4344,7 @@
           <a:bodyPr wrap="square" lIns="254" tIns="254" rIns="254" bIns="254" rtlCol="0" anchor="ctr"/>
           <a:lstStyle/>
           <a:p>
-            <a:pPr indent="0" marL="0">
+            <a:pPr marL="0" indent="0">
               <a:buNone/>
             </a:pPr>
             <a:r>
@@ -4423,6 +4383,13 @@
             <a:tailEnd type="triangle"/>
           </a:ln>
         </p:spPr>
+        <p:txBody>
+          <a:bodyPr/>
+          <a:lstStyle/>
+          <a:p>
+            <a:endParaRPr lang="bg-BG"/>
+          </a:p>
+        </p:txBody>
       </p:sp>
       <p:sp>
         <p:nvSpPr>
@@ -4448,6 +4415,13 @@
             <a:prstDash val="solid"/>
           </a:ln>
         </p:spPr>
+        <p:txBody>
+          <a:bodyPr/>
+          <a:lstStyle/>
+          <a:p>
+            <a:endParaRPr lang="bg-BG"/>
+          </a:p>
+        </p:txBody>
       </p:sp>
       <p:sp>
         <p:nvSpPr>
@@ -4473,6 +4447,13 @@
             <a:prstDash val="solid"/>
           </a:ln>
         </p:spPr>
+        <p:txBody>
+          <a:bodyPr/>
+          <a:lstStyle/>
+          <a:p>
+            <a:endParaRPr lang="bg-BG"/>
+          </a:p>
+        </p:txBody>
       </p:sp>
       <p:sp>
         <p:nvSpPr>
@@ -4495,7 +4476,7 @@
           <a:bodyPr wrap="square" lIns="0" tIns="0" rIns="0" bIns="0" rtlCol="0" anchor="ctr"/>
           <a:lstStyle/>
           <a:p>
-            <a:pPr indent="0" marL="0">
+            <a:pPr marL="0" indent="0">
               <a:buNone/>
             </a:pPr>
             <a:r>
@@ -4531,7 +4512,7 @@
           <a:bodyPr wrap="square" lIns="254" tIns="254" rIns="254" bIns="254" rtlCol="0" anchor="ctr"/>
           <a:lstStyle/>
           <a:p>
-            <a:pPr indent="0" marL="0">
+            <a:pPr marL="0" indent="0">
               <a:buNone/>
             </a:pPr>
             <a:r>
@@ -4570,6 +4551,13 @@
             <a:tailEnd type="triangle"/>
           </a:ln>
         </p:spPr>
+        <p:txBody>
+          <a:bodyPr/>
+          <a:lstStyle/>
+          <a:p>
+            <a:endParaRPr lang="bg-BG"/>
+          </a:p>
+        </p:txBody>
       </p:sp>
       <p:sp>
         <p:nvSpPr>
@@ -4595,6 +4583,13 @@
             <a:prstDash val="solid"/>
           </a:ln>
         </p:spPr>
+        <p:txBody>
+          <a:bodyPr/>
+          <a:lstStyle/>
+          <a:p>
+            <a:endParaRPr lang="bg-BG"/>
+          </a:p>
+        </p:txBody>
       </p:sp>
       <p:sp>
         <p:nvSpPr>
@@ -4620,6 +4615,13 @@
             <a:prstDash val="solid"/>
           </a:ln>
         </p:spPr>
+        <p:txBody>
+          <a:bodyPr/>
+          <a:lstStyle/>
+          <a:p>
+            <a:endParaRPr lang="bg-BG"/>
+          </a:p>
+        </p:txBody>
       </p:sp>
       <p:sp>
         <p:nvSpPr>
@@ -4642,7 +4644,7 @@
           <a:bodyPr wrap="square" lIns="0" tIns="0" rIns="0" bIns="0" rtlCol="0" anchor="ctr"/>
           <a:lstStyle/>
           <a:p>
-            <a:pPr indent="0" marL="0">
+            <a:pPr marL="0" indent="0">
               <a:buNone/>
             </a:pPr>
             <a:r>
@@ -4678,7 +4680,7 @@
           <a:bodyPr wrap="square" lIns="254" tIns="254" rIns="254" bIns="254" rtlCol="0" anchor="ctr"/>
           <a:lstStyle/>
           <a:p>
-            <a:pPr indent="0" marL="0">
+            <a:pPr marL="0" indent="0">
               <a:buNone/>
             </a:pPr>
             <a:r>
@@ -4717,6 +4719,13 @@
             <a:tailEnd type="triangle"/>
           </a:ln>
         </p:spPr>
+        <p:txBody>
+          <a:bodyPr/>
+          <a:lstStyle/>
+          <a:p>
+            <a:endParaRPr lang="bg-BG"/>
+          </a:p>
+        </p:txBody>
       </p:sp>
       <p:sp>
         <p:nvSpPr>
@@ -4742,6 +4751,13 @@
             <a:prstDash val="solid"/>
           </a:ln>
         </p:spPr>
+        <p:txBody>
+          <a:bodyPr/>
+          <a:lstStyle/>
+          <a:p>
+            <a:endParaRPr lang="bg-BG"/>
+          </a:p>
+        </p:txBody>
       </p:sp>
       <p:sp>
         <p:nvSpPr>
@@ -4767,6 +4783,13 @@
             <a:prstDash val="solid"/>
           </a:ln>
         </p:spPr>
+        <p:txBody>
+          <a:bodyPr/>
+          <a:lstStyle/>
+          <a:p>
+            <a:endParaRPr lang="bg-BG"/>
+          </a:p>
+        </p:txBody>
       </p:sp>
       <p:sp>
         <p:nvSpPr>
@@ -4789,7 +4812,7 @@
           <a:bodyPr wrap="square" lIns="0" tIns="0" rIns="0" bIns="0" rtlCol="0" anchor="ctr"/>
           <a:lstStyle/>
           <a:p>
-            <a:pPr indent="0" marL="0">
+            <a:pPr marL="0" indent="0">
               <a:buNone/>
             </a:pPr>
             <a:r>
@@ -4825,7 +4848,7 @@
           <a:bodyPr wrap="square" lIns="254" tIns="254" rIns="254" bIns="254" rtlCol="0" anchor="ctr"/>
           <a:lstStyle/>
           <a:p>
-            <a:pPr indent="0" marL="0">
+            <a:pPr marL="0" indent="0">
               <a:buNone/>
             </a:pPr>
             <a:r>
@@ -4860,7 +4883,7 @@
           </a:prstGeom>
           <a:extLst>
             <a:ext uri="{C572A759-6A51-4108-AA02-DFA0A04FC94B}">
-              <ma14:wrappingTextBoxFlag xmlns:ma14="http://schemas.microsoft.com/office/mac/drawingml/2011/main" val="0"/>
+              <ma14:wrappingTextBoxFlag xmlns:ma14="http://schemas.microsoft.com/office/mac/drawingml/2011/main" xmlns="" val="0"/>
             </a:ext>
           </a:extLst>
         </p:spPr>
@@ -4881,7 +4904,7 @@
           <a:p>
             <a:pPr algn="r"/>
             <a:fld id="{F7021451-1387-4CA6-816F-3879F97B5CBC}" type="slidenum">
-              <a:rPr b="0" lang="en-US"/>
+              <a:rPr lang="en-US" b="0"/>
               <a:t>3</a:t>
             </a:fld>
             <a:endParaRPr lang="en-US"/>
@@ -4934,7 +4957,7 @@
           <a:bodyPr wrap="square" lIns="0" tIns="0" rIns="0" bIns="0" rtlCol="0" anchor="ctr"/>
           <a:lstStyle/>
           <a:p>
-            <a:pPr indent="0" marL="0">
+            <a:pPr marL="0" indent="0">
               <a:buNone/>
             </a:pPr>
             <a:r>
@@ -4973,7 +4996,7 @@
           <a:bodyPr wrap="square" lIns="0" tIns="0" rIns="0" bIns="0" rtlCol="0" anchor="ctr"/>
           <a:lstStyle/>
           <a:p>
-            <a:pPr indent="0" marL="0">
+            <a:pPr marL="0" indent="0">
               <a:buNone/>
             </a:pPr>
             <a:r>
@@ -5015,6 +5038,13 @@
             <a:prstDash val="solid"/>
           </a:ln>
         </p:spPr>
+        <p:txBody>
+          <a:bodyPr/>
+          <a:lstStyle/>
+          <a:p>
+            <a:endParaRPr lang="bg-BG"/>
+          </a:p>
+        </p:txBody>
       </p:sp>
       <p:sp>
         <p:nvSpPr>
@@ -5037,7 +5067,7 @@
           <a:bodyPr wrap="square" lIns="0" tIns="0" rIns="0" bIns="0" rtlCol="0" anchor="ctr"/>
           <a:lstStyle/>
           <a:p>
-            <a:pPr algn="ctr" indent="0" marL="0">
+            <a:pPr marL="0" indent="0" algn="ctr">
               <a:buNone/>
             </a:pPr>
             <a:r>
@@ -5074,6 +5104,13 @@
             <a:prstDash val="solid"/>
           </a:ln>
         </p:spPr>
+        <p:txBody>
+          <a:bodyPr/>
+          <a:lstStyle/>
+          <a:p>
+            <a:endParaRPr lang="bg-BG"/>
+          </a:p>
+        </p:txBody>
       </p:sp>
       <p:sp>
         <p:nvSpPr>
@@ -5096,7 +5133,7 @@
           <a:bodyPr wrap="square" lIns="254" tIns="254" rIns="254" bIns="254" rtlCol="0" anchor="ctr"/>
           <a:lstStyle/>
           <a:p>
-            <a:pPr indent="0" marL="0">
+            <a:pPr marL="0" indent="0">
               <a:buNone/>
             </a:pPr>
             <a:r>
@@ -5110,7 +5147,7 @@
             <a:endParaRPr lang="en-US" sz="1400" dirty="0"/>
           </a:p>
           <a:p>
-            <a:pPr indent="0" marL="0">
+            <a:pPr marL="0" indent="0">
               <a:buNone/>
             </a:pPr>
             <a:r>
@@ -5124,7 +5161,7 @@
             <a:endParaRPr lang="en-US" sz="1400" dirty="0"/>
           </a:p>
           <a:p>
-            <a:pPr indent="0" marL="0">
+            <a:pPr marL="0" indent="0">
               <a:buNone/>
             </a:pPr>
             <a:r>
@@ -5163,6 +5200,13 @@
             <a:prstDash val="solid"/>
           </a:ln>
         </p:spPr>
+        <p:txBody>
+          <a:bodyPr/>
+          <a:lstStyle/>
+          <a:p>
+            <a:endParaRPr lang="bg-BG"/>
+          </a:p>
+        </p:txBody>
       </p:sp>
       <p:sp>
         <p:nvSpPr>
@@ -5185,7 +5229,7 @@
           <a:bodyPr wrap="square" lIns="0" tIns="0" rIns="0" bIns="0" rtlCol="0" anchor="ctr"/>
           <a:lstStyle/>
           <a:p>
-            <a:pPr algn="ctr" indent="0" marL="0">
+            <a:pPr marL="0" indent="0" algn="ctr">
               <a:buNone/>
             </a:pPr>
             <a:r>
@@ -5222,6 +5266,13 @@
             <a:prstDash val="solid"/>
           </a:ln>
         </p:spPr>
+        <p:txBody>
+          <a:bodyPr/>
+          <a:lstStyle/>
+          <a:p>
+            <a:endParaRPr lang="bg-BG"/>
+          </a:p>
+        </p:txBody>
       </p:sp>
       <p:sp>
         <p:nvSpPr>
@@ -5244,7 +5295,7 @@
           <a:bodyPr wrap="square" lIns="254" tIns="254" rIns="254" bIns="254" rtlCol="0" anchor="ctr"/>
           <a:lstStyle/>
           <a:p>
-            <a:pPr indent="0" marL="0">
+            <a:pPr marL="0" indent="0">
               <a:buNone/>
             </a:pPr>
             <a:r>
@@ -5258,7 +5309,7 @@
             <a:endParaRPr lang="en-US" sz="1350" dirty="0"/>
           </a:p>
           <a:p>
-            <a:pPr indent="0" marL="0">
+            <a:pPr marL="0" indent="0">
               <a:buNone/>
             </a:pPr>
             <a:r>
@@ -5272,7 +5323,7 @@
             <a:endParaRPr lang="en-US" sz="1350" dirty="0"/>
           </a:p>
           <a:p>
-            <a:pPr indent="0" marL="0">
+            <a:pPr marL="0" indent="0">
               <a:buNone/>
             </a:pPr>
             <a:r>
@@ -5286,7 +5337,7 @@
             <a:endParaRPr lang="en-US" sz="1350" dirty="0"/>
           </a:p>
           <a:p>
-            <a:pPr indent="0" marL="0">
+            <a:pPr marL="0" indent="0">
               <a:buNone/>
             </a:pPr>
             <a:r>
@@ -5300,7 +5351,7 @@
             <a:endParaRPr lang="en-US" sz="1350" dirty="0"/>
           </a:p>
           <a:p>
-            <a:pPr indent="0" marL="0">
+            <a:pPr marL="0" indent="0">
               <a:buNone/>
             </a:pPr>
             <a:r>
@@ -5314,7 +5365,7 @@
             <a:endParaRPr lang="en-US" sz="1350" dirty="0"/>
           </a:p>
           <a:p>
-            <a:pPr indent="0" marL="0">
+            <a:pPr marL="0" indent="0">
               <a:buNone/>
             </a:pPr>
             <a:r>
@@ -5353,6 +5404,13 @@
             <a:tailEnd type="triangle"/>
           </a:ln>
         </p:spPr>
+        <p:txBody>
+          <a:bodyPr/>
+          <a:lstStyle/>
+          <a:p>
+            <a:endParaRPr lang="bg-BG"/>
+          </a:p>
+        </p:txBody>
       </p:sp>
       <p:sp>
         <p:nvSpPr>
@@ -5375,7 +5433,7 @@
           <a:bodyPr wrap="square" lIns="0" tIns="0" rIns="0" bIns="0" rtlCol="0" anchor="ctr"/>
           <a:lstStyle/>
           <a:p>
-            <a:pPr indent="0" marL="0">
+            <a:pPr marL="0" indent="0">
               <a:buNone/>
             </a:pPr>
             <a:r>
@@ -5411,7 +5469,7 @@
           <a:bodyPr wrap="square" lIns="0" tIns="0" rIns="0" bIns="0" rtlCol="0" anchor="ctr"/>
           <a:lstStyle/>
           <a:p>
-            <a:pPr indent="0" marL="0">
+            <a:pPr marL="0" indent="0">
               <a:buNone/>
             </a:pPr>
             <a:r>
@@ -5447,7 +5505,7 @@
           <a:bodyPr wrap="square" lIns="0" tIns="0" rIns="0" bIns="0" rtlCol="0" anchor="ctr"/>
           <a:lstStyle/>
           <a:p>
-            <a:pPr algn="ctr" indent="0" marL="0">
+            <a:pPr marL="0" indent="0" algn="ctr">
               <a:buNone/>
             </a:pPr>
             <a:r>
@@ -5488,13 +5546,20 @@
             <a:prstDash val="solid"/>
           </a:ln>
           <a:effectLst>
-            <a:outerShdw sx="100000" sy="100000" kx="0" ky="0" algn="bl" rotWithShape="0" blurRad="12700" dist="50800" dir="2700000">
+            <a:outerShdw blurRad="12700" dist="50800" dir="2700000" algn="bl" rotWithShape="0">
               <a:srgbClr val="B8C4D1">
                 <a:alpha val="16000"/>
               </a:srgbClr>
             </a:outerShdw>
           </a:effectLst>
         </p:spPr>
+        <p:txBody>
+          <a:bodyPr/>
+          <a:lstStyle/>
+          <a:p>
+            <a:endParaRPr lang="bg-BG"/>
+          </a:p>
+        </p:txBody>
       </p:sp>
       <p:sp>
         <p:nvSpPr>
@@ -5520,6 +5585,13 @@
             <a:prstDash val="solid"/>
           </a:ln>
         </p:spPr>
+        <p:txBody>
+          <a:bodyPr/>
+          <a:lstStyle/>
+          <a:p>
+            <a:endParaRPr lang="bg-BG"/>
+          </a:p>
+        </p:txBody>
       </p:sp>
       <p:sp>
         <p:nvSpPr>
@@ -5542,7 +5614,7 @@
           <a:bodyPr wrap="square" lIns="0" tIns="0" rIns="0" bIns="0" rtlCol="0" anchor="ctr"/>
           <a:lstStyle/>
           <a:p>
-            <a:pPr indent="0" marL="0">
+            <a:pPr marL="0" indent="0">
               <a:buNone/>
             </a:pPr>
             <a:r>
@@ -5578,7 +5650,7 @@
           <a:bodyPr wrap="square" lIns="254" tIns="254" rIns="254" bIns="254" rtlCol="0" anchor="t"/>
           <a:lstStyle/>
           <a:p>
-            <a:pPr indent="0" marL="0">
+            <a:pPr marL="0" indent="0">
               <a:buNone/>
             </a:pPr>
             <a:r>
@@ -5619,13 +5691,20 @@
             <a:prstDash val="solid"/>
           </a:ln>
           <a:effectLst>
-            <a:outerShdw sx="100000" sy="100000" kx="0" ky="0" algn="bl" rotWithShape="0" blurRad="12700" dist="50800" dir="2700000">
+            <a:outerShdw blurRad="12700" dist="50800" dir="2700000" algn="bl" rotWithShape="0">
               <a:srgbClr val="B8C4D1">
                 <a:alpha val="16000"/>
               </a:srgbClr>
             </a:outerShdw>
           </a:effectLst>
         </p:spPr>
+        <p:txBody>
+          <a:bodyPr/>
+          <a:lstStyle/>
+          <a:p>
+            <a:endParaRPr lang="bg-BG"/>
+          </a:p>
+        </p:txBody>
       </p:sp>
       <p:sp>
         <p:nvSpPr>
@@ -5651,6 +5730,13 @@
             <a:prstDash val="solid"/>
           </a:ln>
         </p:spPr>
+        <p:txBody>
+          <a:bodyPr/>
+          <a:lstStyle/>
+          <a:p>
+            <a:endParaRPr lang="bg-BG"/>
+          </a:p>
+        </p:txBody>
       </p:sp>
       <p:sp>
         <p:nvSpPr>
@@ -5673,7 +5759,7 @@
           <a:bodyPr wrap="square" lIns="0" tIns="0" rIns="0" bIns="0" rtlCol="0" anchor="ctr"/>
           <a:lstStyle/>
           <a:p>
-            <a:pPr indent="0" marL="0">
+            <a:pPr marL="0" indent="0">
               <a:buNone/>
             </a:pPr>
             <a:r>
@@ -5709,7 +5795,7 @@
           <a:bodyPr wrap="square" lIns="254" tIns="254" rIns="254" bIns="254" rtlCol="0" anchor="t"/>
           <a:lstStyle/>
           <a:p>
-            <a:pPr indent="0" marL="0">
+            <a:pPr marL="0" indent="0">
               <a:buNone/>
             </a:pPr>
             <a:r>
@@ -5750,13 +5836,20 @@
             <a:prstDash val="solid"/>
           </a:ln>
           <a:effectLst>
-            <a:outerShdw sx="100000" sy="100000" kx="0" ky="0" algn="bl" rotWithShape="0" blurRad="12700" dist="50800" dir="2700000">
+            <a:outerShdw blurRad="12700" dist="50800" dir="2700000" algn="bl" rotWithShape="0">
               <a:srgbClr val="B8C4D1">
                 <a:alpha val="16000"/>
               </a:srgbClr>
             </a:outerShdw>
           </a:effectLst>
         </p:spPr>
+        <p:txBody>
+          <a:bodyPr/>
+          <a:lstStyle/>
+          <a:p>
+            <a:endParaRPr lang="bg-BG"/>
+          </a:p>
+        </p:txBody>
       </p:sp>
       <p:sp>
         <p:nvSpPr>
@@ -5782,6 +5875,13 @@
             <a:prstDash val="solid"/>
           </a:ln>
         </p:spPr>
+        <p:txBody>
+          <a:bodyPr/>
+          <a:lstStyle/>
+          <a:p>
+            <a:endParaRPr lang="bg-BG"/>
+          </a:p>
+        </p:txBody>
       </p:sp>
       <p:sp>
         <p:nvSpPr>
@@ -5804,7 +5904,7 @@
           <a:bodyPr wrap="square" lIns="0" tIns="0" rIns="0" bIns="0" rtlCol="0" anchor="ctr"/>
           <a:lstStyle/>
           <a:p>
-            <a:pPr indent="0" marL="0">
+            <a:pPr marL="0" indent="0">
               <a:buNone/>
             </a:pPr>
             <a:r>
@@ -5840,7 +5940,7 @@
           <a:bodyPr wrap="square" lIns="254" tIns="254" rIns="254" bIns="254" rtlCol="0" anchor="t"/>
           <a:lstStyle/>
           <a:p>
-            <a:pPr indent="0" marL="0">
+            <a:pPr marL="0" indent="0">
               <a:buNone/>
             </a:pPr>
             <a:r>
@@ -5857,7 +5957,7 @@
       </p:sp>
       <p:sp>
         <p:nvSpPr>
-          <p:cNvPr id="25" name="Slide Number Placeholder 0"/>
+          <p:cNvPr id="28" name="Slide Number Placeholder 0"/>
           <p:cNvSpPr>
             <a:spLocks noGrp="1"/>
           </p:cNvSpPr>
@@ -5875,7 +5975,7 @@
           </a:prstGeom>
           <a:extLst>
             <a:ext uri="{C572A759-6A51-4108-AA02-DFA0A04FC94B}">
-              <ma14:wrappingTextBoxFlag xmlns:ma14="http://schemas.microsoft.com/office/mac/drawingml/2011/main" val="0"/>
+              <ma14:wrappingTextBoxFlag xmlns:ma14="http://schemas.microsoft.com/office/mac/drawingml/2011/main" xmlns="" val="0"/>
             </a:ext>
           </a:extLst>
         </p:spPr>
@@ -5896,7 +5996,7 @@
           <a:p>
             <a:pPr algn="r"/>
             <a:fld id="{F7021451-1387-4CA6-816F-3879F97B5CBC}" type="slidenum">
-              <a:rPr b="0" lang="en-US"/>
+              <a:rPr lang="en-US" b="0"/>
               <a:t>4</a:t>
             </a:fld>
             <a:endParaRPr lang="en-US"/>
@@ -5949,7 +6049,7 @@
           <a:bodyPr wrap="square" lIns="0" tIns="0" rIns="0" bIns="0" rtlCol="0" anchor="ctr"/>
           <a:lstStyle/>
           <a:p>
-            <a:pPr indent="0" marL="0">
+            <a:pPr marL="0" indent="0">
               <a:buNone/>
             </a:pPr>
             <a:r>
@@ -5988,7 +6088,7 @@
           <a:bodyPr wrap="square" lIns="0" tIns="0" rIns="0" bIns="0" rtlCol="0" anchor="ctr"/>
           <a:lstStyle/>
           <a:p>
-            <a:pPr indent="0" marL="0">
+            <a:pPr marL="0" indent="0">
               <a:buNone/>
             </a:pPr>
             <a:r>
@@ -6030,17 +6130,24 @@
             <a:prstDash val="solid"/>
           </a:ln>
         </p:spPr>
+        <p:txBody>
+          <a:bodyPr/>
+          <a:lstStyle/>
+          <a:p>
+            <a:endParaRPr lang="bg-BG"/>
+          </a:p>
+        </p:txBody>
       </p:sp>
       <p:pic>
         <p:nvPicPr>
-          <p:cNvPr id="5" name="Image 0" descr="/mnt/data/Screenshot 2026-09-23 195105.png">    </p:cNvPr>
+          <p:cNvPr id="5" name="Image 0" descr="/mnt/data/Screenshot 2026-09-23 195105.png"/>
           <p:cNvPicPr>
             <a:picLocks noChangeAspect="1"/>
           </p:cNvPicPr>
           <p:nvPr/>
         </p:nvPicPr>
         <p:blipFill>
-          <a:blip r:embed="rId1"/>
+          <a:blip r:embed="rId3"/>
           <a:stretch>
             <a:fillRect/>
           </a:stretch>
@@ -6076,7 +6183,7 @@
           <a:bodyPr wrap="square" lIns="0" tIns="0" rIns="0" bIns="0" rtlCol="0" anchor="ctr"/>
           <a:lstStyle/>
           <a:p>
-            <a:pPr indent="0" marL="0">
+            <a:pPr marL="0" indent="0">
               <a:buNone/>
             </a:pPr>
             <a:r>
@@ -6115,6 +6222,13 @@
             <a:prstDash val="solid"/>
           </a:ln>
         </p:spPr>
+        <p:txBody>
+          <a:bodyPr/>
+          <a:lstStyle/>
+          <a:p>
+            <a:endParaRPr lang="bg-BG"/>
+          </a:p>
+        </p:txBody>
       </p:sp>
       <p:sp>
         <p:nvSpPr>
@@ -6137,7 +6251,7 @@
           <a:bodyPr wrap="square" lIns="0" tIns="0" rIns="0" bIns="0" rtlCol="0" anchor="ctr"/>
           <a:lstStyle/>
           <a:p>
-            <a:pPr indent="0" marL="0">
+            <a:pPr marL="0" indent="0">
               <a:buNone/>
             </a:pPr>
             <a:r>
@@ -6173,7 +6287,7 @@
           <a:bodyPr wrap="square" lIns="0" tIns="0" rIns="0" bIns="0" rtlCol="0" anchor="ctr"/>
           <a:lstStyle/>
           <a:p>
-            <a:pPr indent="0" marL="0">
+            <a:pPr marL="0" indent="0">
               <a:buNone/>
             </a:pPr>
             <a:r>
@@ -6212,6 +6326,13 @@
             <a:prstDash val="solid"/>
           </a:ln>
         </p:spPr>
+        <p:txBody>
+          <a:bodyPr/>
+          <a:lstStyle/>
+          <a:p>
+            <a:endParaRPr lang="bg-BG"/>
+          </a:p>
+        </p:txBody>
       </p:sp>
       <p:sp>
         <p:nvSpPr>
@@ -6234,7 +6355,7 @@
           <a:bodyPr wrap="square" lIns="0" tIns="0" rIns="0" bIns="0" rtlCol="0" anchor="ctr"/>
           <a:lstStyle/>
           <a:p>
-            <a:pPr indent="0" marL="0">
+            <a:pPr marL="0" indent="0">
               <a:buNone/>
             </a:pPr>
             <a:r>
@@ -6270,7 +6391,7 @@
           <a:bodyPr wrap="square" lIns="0" tIns="0" rIns="0" bIns="0" rtlCol="0" anchor="ctr"/>
           <a:lstStyle/>
           <a:p>
-            <a:pPr indent="0" marL="0">
+            <a:pPr marL="0" indent="0">
               <a:buNone/>
             </a:pPr>
             <a:r>
@@ -6309,6 +6430,13 @@
             <a:prstDash val="solid"/>
           </a:ln>
         </p:spPr>
+        <p:txBody>
+          <a:bodyPr/>
+          <a:lstStyle/>
+          <a:p>
+            <a:endParaRPr lang="bg-BG"/>
+          </a:p>
+        </p:txBody>
       </p:sp>
       <p:sp>
         <p:nvSpPr>
@@ -6331,7 +6459,7 @@
           <a:bodyPr wrap="square" lIns="0" tIns="0" rIns="0" bIns="0" rtlCol="0" anchor="ctr"/>
           <a:lstStyle/>
           <a:p>
-            <a:pPr indent="0" marL="0">
+            <a:pPr marL="0" indent="0">
               <a:buNone/>
             </a:pPr>
             <a:r>
@@ -6367,7 +6495,7 @@
           <a:bodyPr wrap="square" lIns="0" tIns="0" rIns="0" bIns="0" rtlCol="0" anchor="ctr"/>
           <a:lstStyle/>
           <a:p>
-            <a:pPr indent="0" marL="0">
+            <a:pPr marL="0" indent="0">
               <a:buNone/>
             </a:pPr>
             <a:r>
@@ -6406,6 +6534,13 @@
             <a:prstDash val="solid"/>
           </a:ln>
         </p:spPr>
+        <p:txBody>
+          <a:bodyPr/>
+          <a:lstStyle/>
+          <a:p>
+            <a:endParaRPr lang="bg-BG"/>
+          </a:p>
+        </p:txBody>
       </p:sp>
       <p:sp>
         <p:nvSpPr>
@@ -6428,7 +6563,7 @@
           <a:bodyPr wrap="square" lIns="0" tIns="0" rIns="0" bIns="0" rtlCol="0" anchor="ctr"/>
           <a:lstStyle/>
           <a:p>
-            <a:pPr indent="0" marL="0">
+            <a:pPr marL="0" indent="0">
               <a:buNone/>
             </a:pPr>
             <a:r>
@@ -6464,7 +6599,7 @@
           <a:bodyPr wrap="square" lIns="0" tIns="0" rIns="0" bIns="0" rtlCol="0" anchor="ctr"/>
           <a:lstStyle/>
           <a:p>
-            <a:pPr indent="0" marL="0">
+            <a:pPr marL="0" indent="0">
               <a:buNone/>
             </a:pPr>
             <a:r>
@@ -6503,6 +6638,13 @@
             <a:prstDash val="solid"/>
           </a:ln>
         </p:spPr>
+        <p:txBody>
+          <a:bodyPr/>
+          <a:lstStyle/>
+          <a:p>
+            <a:endParaRPr lang="bg-BG"/>
+          </a:p>
+        </p:txBody>
       </p:sp>
       <p:sp>
         <p:nvSpPr>
@@ -6525,7 +6667,7 @@
           <a:bodyPr wrap="square" lIns="0" tIns="0" rIns="0" bIns="0" rtlCol="0" anchor="ctr"/>
           <a:lstStyle/>
           <a:p>
-            <a:pPr indent="0" marL="0">
+            <a:pPr marL="0" indent="0">
               <a:buNone/>
             </a:pPr>
             <a:r>
@@ -6561,7 +6703,7 @@
           <a:bodyPr wrap="square" lIns="0" tIns="0" rIns="0" bIns="0" rtlCol="0" anchor="ctr"/>
           <a:lstStyle/>
           <a:p>
-            <a:pPr indent="0" marL="0">
+            <a:pPr marL="0" indent="0">
               <a:buNone/>
             </a:pPr>
             <a:r>
@@ -6596,7 +6738,7 @@
           </a:prstGeom>
           <a:extLst>
             <a:ext uri="{C572A759-6A51-4108-AA02-DFA0A04FC94B}">
-              <ma14:wrappingTextBoxFlag xmlns:ma14="http://schemas.microsoft.com/office/mac/drawingml/2011/main" val="0"/>
+              <ma14:wrappingTextBoxFlag xmlns:ma14="http://schemas.microsoft.com/office/mac/drawingml/2011/main" xmlns="" val="0"/>
             </a:ext>
           </a:extLst>
         </p:spPr>
@@ -6617,7 +6759,7 @@
           <a:p>
             <a:pPr algn="r"/>
             <a:fld id="{F7021451-1387-4CA6-816F-3879F97B5CBC}" type="slidenum">
-              <a:rPr b="0" lang="en-US"/>
+              <a:rPr lang="en-US" b="0"/>
               <a:t>5</a:t>
             </a:fld>
             <a:endParaRPr lang="en-US"/>
@@ -6670,7 +6812,7 @@
           <a:bodyPr wrap="square" lIns="0" tIns="0" rIns="0" bIns="0" rtlCol="0" anchor="ctr"/>
           <a:lstStyle/>
           <a:p>
-            <a:pPr indent="0" marL="0">
+            <a:pPr marL="0" indent="0">
               <a:buNone/>
             </a:pPr>
             <a:r>
@@ -6709,7 +6851,7 @@
           <a:bodyPr wrap="square" lIns="0" tIns="0" rIns="0" bIns="0" rtlCol="0" anchor="ctr"/>
           <a:lstStyle/>
           <a:p>
-            <a:pPr indent="0" marL="0">
+            <a:pPr marL="0" indent="0">
               <a:buNone/>
             </a:pPr>
             <a:r>
@@ -6753,13 +6895,20 @@
             <a:prstDash val="solid"/>
           </a:ln>
           <a:effectLst>
-            <a:outerShdw sx="100000" sy="100000" kx="0" ky="0" algn="bl" rotWithShape="0" blurRad="12700" dist="50800" dir="2700000">
+            <a:outerShdw blurRad="12700" dist="50800" dir="2700000" algn="bl" rotWithShape="0">
               <a:srgbClr val="B8C4D1">
                 <a:alpha val="16000"/>
               </a:srgbClr>
             </a:outerShdw>
           </a:effectLst>
         </p:spPr>
+        <p:txBody>
+          <a:bodyPr/>
+          <a:lstStyle/>
+          <a:p>
+            <a:endParaRPr lang="bg-BG"/>
+          </a:p>
+        </p:txBody>
       </p:sp>
       <p:sp>
         <p:nvSpPr>
@@ -6785,6 +6934,13 @@
             <a:prstDash val="solid"/>
           </a:ln>
         </p:spPr>
+        <p:txBody>
+          <a:bodyPr/>
+          <a:lstStyle/>
+          <a:p>
+            <a:endParaRPr lang="bg-BG"/>
+          </a:p>
+        </p:txBody>
       </p:sp>
       <p:sp>
         <p:nvSpPr>
@@ -6807,7 +6963,7 @@
           <a:bodyPr wrap="square" lIns="0" tIns="0" rIns="0" bIns="0" rtlCol="0" anchor="ctr"/>
           <a:lstStyle/>
           <a:p>
-            <a:pPr indent="0" marL="0">
+            <a:pPr marL="0" indent="0">
               <a:buNone/>
             </a:pPr>
             <a:r>
@@ -6843,7 +6999,7 @@
           <a:bodyPr wrap="square" lIns="254" tIns="254" rIns="254" bIns="254" rtlCol="0" anchor="t"/>
           <a:lstStyle/>
           <a:p>
-            <a:pPr indent="0" marL="0">
+            <a:pPr marL="0" indent="0">
               <a:buNone/>
             </a:pPr>
             <a:r>
@@ -6884,13 +7040,20 @@
             <a:prstDash val="solid"/>
           </a:ln>
           <a:effectLst>
-            <a:outerShdw sx="100000" sy="100000" kx="0" ky="0" algn="bl" rotWithShape="0" blurRad="12700" dist="50800" dir="2700000">
+            <a:outerShdw blurRad="12700" dist="50800" dir="2700000" algn="bl" rotWithShape="0">
               <a:srgbClr val="B8C4D1">
                 <a:alpha val="16000"/>
               </a:srgbClr>
             </a:outerShdw>
           </a:effectLst>
         </p:spPr>
+        <p:txBody>
+          <a:bodyPr/>
+          <a:lstStyle/>
+          <a:p>
+            <a:endParaRPr lang="bg-BG"/>
+          </a:p>
+        </p:txBody>
       </p:sp>
       <p:sp>
         <p:nvSpPr>
@@ -6916,6 +7079,13 @@
             <a:prstDash val="solid"/>
           </a:ln>
         </p:spPr>
+        <p:txBody>
+          <a:bodyPr/>
+          <a:lstStyle/>
+          <a:p>
+            <a:endParaRPr lang="bg-BG"/>
+          </a:p>
+        </p:txBody>
       </p:sp>
       <p:sp>
         <p:nvSpPr>
@@ -6938,7 +7108,7 @@
           <a:bodyPr wrap="square" lIns="0" tIns="0" rIns="0" bIns="0" rtlCol="0" anchor="ctr"/>
           <a:lstStyle/>
           <a:p>
-            <a:pPr indent="0" marL="0">
+            <a:pPr marL="0" indent="0">
               <a:buNone/>
             </a:pPr>
             <a:r>
@@ -6974,7 +7144,7 @@
           <a:bodyPr wrap="square" lIns="254" tIns="254" rIns="254" bIns="254" rtlCol="0" anchor="t"/>
           <a:lstStyle/>
           <a:p>
-            <a:pPr indent="0" marL="0">
+            <a:pPr marL="0" indent="0">
               <a:buNone/>
             </a:pPr>
             <a:r>
@@ -7013,6 +7183,13 @@
             <a:prstDash val="solid"/>
           </a:ln>
         </p:spPr>
+        <p:txBody>
+          <a:bodyPr/>
+          <a:lstStyle/>
+          <a:p>
+            <a:endParaRPr lang="bg-BG"/>
+          </a:p>
+        </p:txBody>
       </p:sp>
       <p:sp>
         <p:nvSpPr>
@@ -7035,7 +7212,7 @@
           <a:bodyPr wrap="square" lIns="0" tIns="0" rIns="0" bIns="0" rtlCol="0" anchor="ctr"/>
           <a:lstStyle/>
           <a:p>
-            <a:pPr algn="ctr" indent="0" marL="0">
+            <a:pPr marL="0" indent="0" algn="ctr">
               <a:buNone/>
             </a:pPr>
             <a:r>
@@ -7071,7 +7248,7 @@
           <a:bodyPr wrap="square" lIns="0" tIns="0" rIns="0" bIns="0" rtlCol="0" anchor="ctr"/>
           <a:lstStyle/>
           <a:p>
-            <a:pPr algn="ctr" indent="0" marL="0">
+            <a:pPr marL="0" indent="0" algn="ctr">
               <a:buNone/>
             </a:pPr>
             <a:r>
@@ -7110,6 +7287,13 @@
             <a:tailEnd type="triangle"/>
           </a:ln>
         </p:spPr>
+        <p:txBody>
+          <a:bodyPr/>
+          <a:lstStyle/>
+          <a:p>
+            <a:endParaRPr lang="bg-BG"/>
+          </a:p>
+        </p:txBody>
       </p:sp>
       <p:sp>
         <p:nvSpPr>
@@ -7120,7 +7304,7 @@
         <p:spPr>
           <a:xfrm>
             <a:off x="3749040" y="4498848"/>
-            <a:ext cx="749808" cy="-841248"/>
+            <a:ext cx="749808" cy="0"/>
           </a:xfrm>
           <a:prstGeom prst="line">
             <a:avLst/>
@@ -7135,6 +7319,13 @@
             <a:tailEnd type="triangle"/>
           </a:ln>
         </p:spPr>
+        <p:txBody>
+          <a:bodyPr/>
+          <a:lstStyle/>
+          <a:p>
+            <a:endParaRPr lang="bg-BG"/>
+          </a:p>
+        </p:txBody>
       </p:sp>
       <p:sp>
         <p:nvSpPr>
@@ -7160,6 +7351,13 @@
             <a:prstDash val="solid"/>
           </a:ln>
         </p:spPr>
+        <p:txBody>
+          <a:bodyPr/>
+          <a:lstStyle/>
+          <a:p>
+            <a:endParaRPr lang="bg-BG"/>
+          </a:p>
+        </p:txBody>
       </p:sp>
       <p:sp>
         <p:nvSpPr>
@@ -7182,7 +7380,7 @@
           <a:bodyPr wrap="square" lIns="0" tIns="0" rIns="0" bIns="0" rtlCol="0" anchor="ctr"/>
           <a:lstStyle/>
           <a:p>
-            <a:pPr algn="ctr" indent="0" marL="0">
+            <a:pPr marL="0" indent="0" algn="ctr">
               <a:buNone/>
             </a:pPr>
             <a:r>
@@ -7218,7 +7416,7 @@
           <a:bodyPr wrap="square" lIns="0" tIns="0" rIns="0" bIns="0" rtlCol="0" anchor="ctr"/>
           <a:lstStyle/>
           <a:p>
-            <a:pPr algn="ctr" indent="0" marL="0">
+            <a:pPr marL="0" indent="0" algn="ctr">
               <a:buNone/>
             </a:pPr>
             <a:r>
@@ -7257,6 +7455,13 @@
             <a:tailEnd type="triangle"/>
           </a:ln>
         </p:spPr>
+        <p:txBody>
+          <a:bodyPr/>
+          <a:lstStyle/>
+          <a:p>
+            <a:endParaRPr lang="bg-BG"/>
+          </a:p>
+        </p:txBody>
       </p:sp>
       <p:sp>
         <p:nvSpPr>
@@ -7279,7 +7484,7 @@
           <a:bodyPr wrap="square" lIns="0" tIns="0" rIns="0" bIns="0" rtlCol="0" anchor="ctr"/>
           <a:lstStyle/>
           <a:p>
-            <a:pPr algn="ctr" indent="0" marL="0">
+            <a:pPr marL="0" indent="0" algn="ctr">
               <a:buNone/>
             </a:pPr>
             <a:r>
@@ -7314,7 +7519,7 @@
           </a:prstGeom>
           <a:extLst>
             <a:ext uri="{C572A759-6A51-4108-AA02-DFA0A04FC94B}">
-              <ma14:wrappingTextBoxFlag xmlns:ma14="http://schemas.microsoft.com/office/mac/drawingml/2011/main" val="0"/>
+              <ma14:wrappingTextBoxFlag xmlns:ma14="http://schemas.microsoft.com/office/mac/drawingml/2011/main" xmlns="" val="0"/>
             </a:ext>
           </a:extLst>
         </p:spPr>
@@ -7335,7 +7540,7 @@
           <a:p>
             <a:pPr algn="r"/>
             <a:fld id="{F7021451-1387-4CA6-816F-3879F97B5CBC}" type="slidenum">
-              <a:rPr b="0" lang="en-US"/>
+              <a:rPr lang="en-US" b="0"/>
               <a:t>6</a:t>
             </a:fld>
             <a:endParaRPr lang="en-US"/>
@@ -7388,7 +7593,7 @@
           <a:bodyPr wrap="square" lIns="0" tIns="0" rIns="0" bIns="0" rtlCol="0" anchor="ctr"/>
           <a:lstStyle/>
           <a:p>
-            <a:pPr indent="0" marL="0">
+            <a:pPr marL="0" indent="0">
               <a:buNone/>
             </a:pPr>
             <a:r>
@@ -7427,7 +7632,7 @@
           <a:bodyPr wrap="square" lIns="0" tIns="0" rIns="0" bIns="0" rtlCol="0" anchor="ctr"/>
           <a:lstStyle/>
           <a:p>
-            <a:pPr indent="0" marL="0">
+            <a:pPr marL="0" indent="0">
               <a:buNone/>
             </a:pPr>
             <a:r>
@@ -7471,13 +7676,20 @@
             <a:prstDash val="solid"/>
           </a:ln>
           <a:effectLst>
-            <a:outerShdw sx="100000" sy="100000" kx="0" ky="0" algn="bl" rotWithShape="0" blurRad="12700" dist="50800" dir="2700000">
+            <a:outerShdw blurRad="12700" dist="50800" dir="2700000" algn="bl" rotWithShape="0">
               <a:srgbClr val="B8C4D1">
                 <a:alpha val="16000"/>
               </a:srgbClr>
             </a:outerShdw>
           </a:effectLst>
         </p:spPr>
+        <p:txBody>
+          <a:bodyPr/>
+          <a:lstStyle/>
+          <a:p>
+            <a:endParaRPr lang="bg-BG"/>
+          </a:p>
+        </p:txBody>
       </p:sp>
       <p:sp>
         <p:nvSpPr>
@@ -7503,6 +7715,13 @@
             <a:prstDash val="solid"/>
           </a:ln>
         </p:spPr>
+        <p:txBody>
+          <a:bodyPr/>
+          <a:lstStyle/>
+          <a:p>
+            <a:endParaRPr lang="bg-BG"/>
+          </a:p>
+        </p:txBody>
       </p:sp>
       <p:sp>
         <p:nvSpPr>
@@ -7525,7 +7744,7 @@
           <a:bodyPr wrap="square" lIns="0" tIns="0" rIns="0" bIns="0" rtlCol="0" anchor="ctr"/>
           <a:lstStyle/>
           <a:p>
-            <a:pPr indent="0" marL="0">
+            <a:pPr marL="0" indent="0">
               <a:buNone/>
             </a:pPr>
             <a:r>
@@ -7561,7 +7780,7 @@
           <a:bodyPr wrap="square" lIns="254" tIns="254" rIns="254" bIns="254" rtlCol="0" anchor="t"/>
           <a:lstStyle/>
           <a:p>
-            <a:pPr indent="0" marL="0">
+            <a:pPr marL="0" indent="0">
               <a:buNone/>
             </a:pPr>
             <a:r>
@@ -7602,13 +7821,20 @@
             <a:prstDash val="solid"/>
           </a:ln>
           <a:effectLst>
-            <a:outerShdw sx="100000" sy="100000" kx="0" ky="0" algn="bl" rotWithShape="0" blurRad="12700" dist="50800" dir="2700000">
+            <a:outerShdw blurRad="12700" dist="50800" dir="2700000" algn="bl" rotWithShape="0">
               <a:srgbClr val="B8C4D1">
                 <a:alpha val="16000"/>
               </a:srgbClr>
             </a:outerShdw>
           </a:effectLst>
         </p:spPr>
+        <p:txBody>
+          <a:bodyPr/>
+          <a:lstStyle/>
+          <a:p>
+            <a:endParaRPr lang="bg-BG"/>
+          </a:p>
+        </p:txBody>
       </p:sp>
       <p:sp>
         <p:nvSpPr>
@@ -7634,6 +7860,13 @@
             <a:prstDash val="solid"/>
           </a:ln>
         </p:spPr>
+        <p:txBody>
+          <a:bodyPr/>
+          <a:lstStyle/>
+          <a:p>
+            <a:endParaRPr lang="bg-BG"/>
+          </a:p>
+        </p:txBody>
       </p:sp>
       <p:sp>
         <p:nvSpPr>
@@ -7656,7 +7889,7 @@
           <a:bodyPr wrap="square" lIns="0" tIns="0" rIns="0" bIns="0" rtlCol="0" anchor="ctr"/>
           <a:lstStyle/>
           <a:p>
-            <a:pPr indent="0" marL="0">
+            <a:pPr marL="0" indent="0">
               <a:buNone/>
             </a:pPr>
             <a:r>
@@ -7692,7 +7925,7 @@
           <a:bodyPr wrap="square" lIns="254" tIns="254" rIns="254" bIns="254" rtlCol="0" anchor="t"/>
           <a:lstStyle/>
           <a:p>
-            <a:pPr indent="0" marL="0">
+            <a:pPr marL="0" indent="0">
               <a:buNone/>
             </a:pPr>
             <a:r>
@@ -7733,13 +7966,20 @@
             <a:prstDash val="solid"/>
           </a:ln>
           <a:effectLst>
-            <a:outerShdw sx="100000" sy="100000" kx="0" ky="0" algn="bl" rotWithShape="0" blurRad="12700" dist="50800" dir="2700000">
+            <a:outerShdw blurRad="12700" dist="50800" dir="2700000" algn="bl" rotWithShape="0">
               <a:srgbClr val="B8C4D1">
                 <a:alpha val="16000"/>
               </a:srgbClr>
             </a:outerShdw>
           </a:effectLst>
         </p:spPr>
+        <p:txBody>
+          <a:bodyPr/>
+          <a:lstStyle/>
+          <a:p>
+            <a:endParaRPr lang="bg-BG"/>
+          </a:p>
+        </p:txBody>
       </p:sp>
       <p:sp>
         <p:nvSpPr>
@@ -7765,6 +8005,13 @@
             <a:prstDash val="solid"/>
           </a:ln>
         </p:spPr>
+        <p:txBody>
+          <a:bodyPr/>
+          <a:lstStyle/>
+          <a:p>
+            <a:endParaRPr lang="bg-BG"/>
+          </a:p>
+        </p:txBody>
       </p:sp>
       <p:sp>
         <p:nvSpPr>
@@ -7787,7 +8034,7 @@
           <a:bodyPr wrap="square" lIns="0" tIns="0" rIns="0" bIns="0" rtlCol="0" anchor="ctr"/>
           <a:lstStyle/>
           <a:p>
-            <a:pPr indent="0" marL="0">
+            <a:pPr marL="0" indent="0">
               <a:buNone/>
             </a:pPr>
             <a:r>
@@ -7823,7 +8070,7 @@
           <a:bodyPr wrap="square" lIns="254" tIns="254" rIns="254" bIns="254" rtlCol="0" anchor="t"/>
           <a:lstStyle/>
           <a:p>
-            <a:pPr indent="0" marL="0">
+            <a:pPr marL="0" indent="0">
               <a:buNone/>
             </a:pPr>
             <a:r>
@@ -7862,6 +8109,13 @@
             <a:prstDash val="solid"/>
           </a:ln>
         </p:spPr>
+        <p:txBody>
+          <a:bodyPr/>
+          <a:lstStyle/>
+          <a:p>
+            <a:endParaRPr lang="bg-BG"/>
+          </a:p>
+        </p:txBody>
       </p:sp>
       <p:sp>
         <p:nvSpPr>
@@ -7887,6 +8141,13 @@
             <a:prstDash val="solid"/>
           </a:ln>
         </p:spPr>
+        <p:txBody>
+          <a:bodyPr/>
+          <a:lstStyle/>
+          <a:p>
+            <a:endParaRPr lang="bg-BG"/>
+          </a:p>
+        </p:txBody>
       </p:sp>
       <p:sp>
         <p:nvSpPr>
@@ -7909,7 +8170,7 @@
           <a:bodyPr wrap="square" lIns="0" tIns="0" rIns="0" bIns="0" rtlCol="0" anchor="ctr"/>
           <a:lstStyle/>
           <a:p>
-            <a:pPr algn="ctr" indent="0" marL="0">
+            <a:pPr marL="0" indent="0" algn="ctr">
               <a:buNone/>
             </a:pPr>
             <a:r>
@@ -7945,7 +8206,7 @@
           <a:bodyPr wrap="square" lIns="0" tIns="0" rIns="0" bIns="0" rtlCol="0" anchor="ctr"/>
           <a:lstStyle/>
           <a:p>
-            <a:pPr algn="ctr" indent="0" marL="0">
+            <a:pPr marL="0" indent="0" algn="ctr">
               <a:buNone/>
             </a:pPr>
             <a:r>
@@ -7959,7 +8220,7 @@
             <a:endParaRPr lang="en-US" sz="1320" dirty="0"/>
           </a:p>
           <a:p>
-            <a:pPr algn="ctr" indent="0" marL="0">
+            <a:pPr marL="0" indent="0" algn="ctr">
               <a:buNone/>
             </a:pPr>
             <a:r>
@@ -7998,6 +8259,13 @@
             <a:prstDash val="solid"/>
           </a:ln>
         </p:spPr>
+        <p:txBody>
+          <a:bodyPr/>
+          <a:lstStyle/>
+          <a:p>
+            <a:endParaRPr lang="bg-BG"/>
+          </a:p>
+        </p:txBody>
       </p:sp>
       <p:sp>
         <p:nvSpPr>
@@ -8025,13 +8293,20 @@
             <a:prstDash val="solid"/>
           </a:ln>
           <a:effectLst>
-            <a:outerShdw sx="100000" sy="100000" kx="0" ky="0" algn="bl" rotWithShape="0" blurRad="12700" dist="50800" dir="2700000">
+            <a:outerShdw blurRad="12700" dist="50800" dir="2700000" algn="bl" rotWithShape="0">
               <a:srgbClr val="B8C4D1">
                 <a:alpha val="16000"/>
               </a:srgbClr>
             </a:outerShdw>
           </a:effectLst>
         </p:spPr>
+        <p:txBody>
+          <a:bodyPr/>
+          <a:lstStyle/>
+          <a:p>
+            <a:endParaRPr lang="bg-BG"/>
+          </a:p>
+        </p:txBody>
       </p:sp>
       <p:sp>
         <p:nvSpPr>
@@ -8057,6 +8332,13 @@
             <a:prstDash val="solid"/>
           </a:ln>
         </p:spPr>
+        <p:txBody>
+          <a:bodyPr/>
+          <a:lstStyle/>
+          <a:p>
+            <a:endParaRPr lang="bg-BG"/>
+          </a:p>
+        </p:txBody>
       </p:sp>
       <p:sp>
         <p:nvSpPr>
@@ -8079,7 +8361,7 @@
           <a:bodyPr wrap="square" lIns="0" tIns="0" rIns="0" bIns="0" rtlCol="0" anchor="ctr"/>
           <a:lstStyle/>
           <a:p>
-            <a:pPr indent="0" marL="0">
+            <a:pPr marL="0" indent="0">
               <a:buNone/>
             </a:pPr>
             <a:r>
@@ -8115,7 +8397,7 @@
           <a:bodyPr wrap="square" lIns="254" tIns="254" rIns="254" bIns="254" rtlCol="0" anchor="t"/>
           <a:lstStyle/>
           <a:p>
-            <a:pPr indent="0" marL="0">
+            <a:pPr marL="0" indent="0">
               <a:buNone/>
             </a:pPr>
             <a:r>
@@ -8129,7 +8411,7 @@
             <a:endParaRPr lang="en-US" sz="1220" dirty="0"/>
           </a:p>
           <a:p>
-            <a:pPr indent="0" marL="0">
+            <a:pPr marL="0" indent="0">
               <a:buNone/>
             </a:pPr>
             <a:r>
@@ -8143,7 +8425,7 @@
             <a:endParaRPr lang="en-US" sz="1220" dirty="0"/>
           </a:p>
           <a:p>
-            <a:pPr indent="0" marL="0">
+            <a:pPr marL="0" indent="0">
               <a:buNone/>
             </a:pPr>
             <a:r>
@@ -8179,7 +8461,7 @@
           <a:bodyPr wrap="square" lIns="0" tIns="0" rIns="0" bIns="0" rtlCol="0" anchor="ctr"/>
           <a:lstStyle/>
           <a:p>
-            <a:pPr algn="ctr" indent="0" marL="0">
+            <a:pPr marL="0" indent="0" algn="ctr">
               <a:buNone/>
             </a:pPr>
             <a:r>
@@ -8196,7 +8478,7 @@
       </p:sp>
       <p:sp>
         <p:nvSpPr>
-          <p:cNvPr id="25" name="Slide Number Placeholder 0"/>
+          <p:cNvPr id="26" name="Slide Number Placeholder 0"/>
           <p:cNvSpPr>
             <a:spLocks noGrp="1"/>
           </p:cNvSpPr>
@@ -8214,7 +8496,7 @@
           </a:prstGeom>
           <a:extLst>
             <a:ext uri="{C572A759-6A51-4108-AA02-DFA0A04FC94B}">
-              <ma14:wrappingTextBoxFlag xmlns:ma14="http://schemas.microsoft.com/office/mac/drawingml/2011/main" val="0"/>
+              <ma14:wrappingTextBoxFlag xmlns:ma14="http://schemas.microsoft.com/office/mac/drawingml/2011/main" xmlns="" val="0"/>
             </a:ext>
           </a:extLst>
         </p:spPr>
@@ -8235,7 +8517,7 @@
           <a:p>
             <a:pPr algn="r"/>
             <a:fld id="{F7021451-1387-4CA6-816F-3879F97B5CBC}" type="slidenum">
-              <a:rPr b="0" lang="en-US"/>
+              <a:rPr lang="en-US" b="0"/>
               <a:t>7</a:t>
             </a:fld>
             <a:endParaRPr lang="en-US"/>
@@ -8288,7 +8570,7 @@
           <a:bodyPr wrap="square" lIns="0" tIns="0" rIns="0" bIns="0" rtlCol="0" anchor="ctr"/>
           <a:lstStyle/>
           <a:p>
-            <a:pPr indent="0" marL="0">
+            <a:pPr marL="0" indent="0">
               <a:buNone/>
             </a:pPr>
             <a:r>
@@ -8327,7 +8609,7 @@
           <a:bodyPr wrap="square" lIns="0" tIns="0" rIns="0" bIns="0" rtlCol="0" anchor="ctr"/>
           <a:lstStyle/>
           <a:p>
-            <a:pPr indent="0" marL="0">
+            <a:pPr marL="0" indent="0">
               <a:buNone/>
             </a:pPr>
             <a:r>
@@ -8366,7 +8648,7 @@
           <a:bodyPr wrap="square" lIns="0" tIns="0" rIns="0" bIns="0" rtlCol="0" anchor="ctr"/>
           <a:lstStyle/>
           <a:p>
-            <a:pPr algn="ctr" indent="0" marL="0">
+            <a:pPr marL="0" indent="0" algn="ctr">
               <a:buNone/>
             </a:pPr>
             <a:r>
@@ -8405,6 +8687,13 @@
             <a:prstDash val="solid"/>
           </a:ln>
         </p:spPr>
+        <p:txBody>
+          <a:bodyPr/>
+          <a:lstStyle/>
+          <a:p>
+            <a:endParaRPr lang="bg-BG"/>
+          </a:p>
+        </p:txBody>
       </p:sp>
       <p:sp>
         <p:nvSpPr>
@@ -8415,7 +8704,7 @@
         <p:spPr>
           <a:xfrm>
             <a:off x="1636776" y="2139696"/>
-            <a:ext cx="-786384" cy="603504"/>
+            <a:ext cx="0" cy="603504"/>
           </a:xfrm>
           <a:prstGeom prst="line">
             <a:avLst/>
@@ -8430,6 +8719,13 @@
             <a:tailEnd type="triangle"/>
           </a:ln>
         </p:spPr>
+        <p:txBody>
+          <a:bodyPr/>
+          <a:lstStyle/>
+          <a:p>
+            <a:endParaRPr lang="bg-BG"/>
+          </a:p>
+        </p:txBody>
       </p:sp>
       <p:sp>
         <p:nvSpPr>
@@ -8455,6 +8751,13 @@
             <a:prstDash val="solid"/>
           </a:ln>
         </p:spPr>
+        <p:txBody>
+          <a:bodyPr/>
+          <a:lstStyle/>
+          <a:p>
+            <a:endParaRPr lang="bg-BG"/>
+          </a:p>
+        </p:txBody>
       </p:sp>
       <p:sp>
         <p:nvSpPr>
@@ -8477,7 +8780,7 @@
           <a:bodyPr wrap="square" lIns="0" tIns="0" rIns="0" bIns="0" rtlCol="0" anchor="ctr"/>
           <a:lstStyle/>
           <a:p>
-            <a:pPr algn="ctr" indent="0" marL="0">
+            <a:pPr marL="0" indent="0" algn="ctr">
               <a:buNone/>
             </a:pPr>
             <a:r>
@@ -8516,6 +8819,13 @@
             <a:tailEnd type="triangle"/>
           </a:ln>
         </p:spPr>
+        <p:txBody>
+          <a:bodyPr/>
+          <a:lstStyle/>
+          <a:p>
+            <a:endParaRPr lang="bg-BG"/>
+          </a:p>
+        </p:txBody>
       </p:sp>
       <p:sp>
         <p:nvSpPr>
@@ -8541,6 +8851,13 @@
             <a:prstDash val="solid"/>
           </a:ln>
         </p:spPr>
+        <p:txBody>
+          <a:bodyPr/>
+          <a:lstStyle/>
+          <a:p>
+            <a:endParaRPr lang="bg-BG"/>
+          </a:p>
+        </p:txBody>
       </p:sp>
       <p:sp>
         <p:nvSpPr>
@@ -8563,7 +8880,7 @@
           <a:bodyPr wrap="square" lIns="0" tIns="0" rIns="0" bIns="0" rtlCol="0" anchor="ctr"/>
           <a:lstStyle/>
           <a:p>
-            <a:pPr algn="ctr" indent="0" marL="0">
+            <a:pPr marL="0" indent="0" algn="ctr">
               <a:buNone/>
             </a:pPr>
             <a:r>
@@ -8602,6 +8919,13 @@
             <a:tailEnd type="triangle"/>
           </a:ln>
         </p:spPr>
+        <p:txBody>
+          <a:bodyPr/>
+          <a:lstStyle/>
+          <a:p>
+            <a:endParaRPr lang="bg-BG"/>
+          </a:p>
+        </p:txBody>
       </p:sp>
       <p:sp>
         <p:nvSpPr>
@@ -8627,6 +8951,13 @@
             <a:prstDash val="solid"/>
           </a:ln>
         </p:spPr>
+        <p:txBody>
+          <a:bodyPr/>
+          <a:lstStyle/>
+          <a:p>
+            <a:endParaRPr lang="bg-BG"/>
+          </a:p>
+        </p:txBody>
       </p:sp>
       <p:sp>
         <p:nvSpPr>
@@ -8649,7 +8980,7 @@
           <a:bodyPr wrap="square" lIns="0" tIns="0" rIns="0" bIns="0" rtlCol="0" anchor="ctr"/>
           <a:lstStyle/>
           <a:p>
-            <a:pPr algn="ctr" indent="0" marL="0">
+            <a:pPr marL="0" indent="0" algn="ctr">
               <a:buNone/>
             </a:pPr>
             <a:r>
@@ -8673,7 +9004,7 @@
         <p:spPr>
           <a:xfrm>
             <a:off x="1673352" y="3072384"/>
-            <a:ext cx="-576072" cy="950976"/>
+            <a:ext cx="0" cy="950976"/>
           </a:xfrm>
           <a:prstGeom prst="line">
             <a:avLst/>
@@ -8688,6 +9019,13 @@
             <a:tailEnd type="triangle"/>
           </a:ln>
         </p:spPr>
+        <p:txBody>
+          <a:bodyPr/>
+          <a:lstStyle/>
+          <a:p>
+            <a:endParaRPr lang="bg-BG"/>
+          </a:p>
+        </p:txBody>
       </p:sp>
       <p:sp>
         <p:nvSpPr>
@@ -8713,6 +9051,13 @@
             <a:tailEnd type="triangle"/>
           </a:ln>
         </p:spPr>
+        <p:txBody>
+          <a:bodyPr/>
+          <a:lstStyle/>
+          <a:p>
+            <a:endParaRPr lang="bg-BG"/>
+          </a:p>
+        </p:txBody>
       </p:sp>
       <p:sp>
         <p:nvSpPr>
@@ -8738,6 +9083,13 @@
             <a:tailEnd type="triangle"/>
           </a:ln>
         </p:spPr>
+        <p:txBody>
+          <a:bodyPr/>
+          <a:lstStyle/>
+          <a:p>
+            <a:endParaRPr lang="bg-BG"/>
+          </a:p>
+        </p:txBody>
       </p:sp>
       <p:sp>
         <p:nvSpPr>
@@ -8763,6 +9115,13 @@
             <a:prstDash val="solid"/>
           </a:ln>
         </p:spPr>
+        <p:txBody>
+          <a:bodyPr/>
+          <a:lstStyle/>
+          <a:p>
+            <a:endParaRPr lang="bg-BG"/>
+          </a:p>
+        </p:txBody>
       </p:sp>
       <p:sp>
         <p:nvSpPr>
@@ -8788,6 +9147,13 @@
             <a:prstDash val="solid"/>
           </a:ln>
         </p:spPr>
+        <p:txBody>
+          <a:bodyPr/>
+          <a:lstStyle/>
+          <a:p>
+            <a:endParaRPr lang="bg-BG"/>
+          </a:p>
+        </p:txBody>
       </p:sp>
       <p:sp>
         <p:nvSpPr>
@@ -8813,6 +9179,13 @@
             <a:prstDash val="solid"/>
           </a:ln>
         </p:spPr>
+        <p:txBody>
+          <a:bodyPr/>
+          <a:lstStyle/>
+          <a:p>
+            <a:endParaRPr lang="bg-BG"/>
+          </a:p>
+        </p:txBody>
       </p:sp>
       <p:sp>
         <p:nvSpPr>
@@ -8835,7 +9208,7 @@
           <a:bodyPr wrap="square" lIns="0" tIns="0" rIns="0" bIns="0" rtlCol="0" anchor="ctr"/>
           <a:lstStyle/>
           <a:p>
-            <a:pPr algn="ctr" indent="0" marL="0">
+            <a:pPr marL="0" indent="0" algn="ctr">
               <a:buNone/>
             </a:pPr>
             <a:r>
@@ -8872,6 +9245,13 @@
             <a:prstDash val="solid"/>
           </a:ln>
         </p:spPr>
+        <p:txBody>
+          <a:bodyPr/>
+          <a:lstStyle/>
+          <a:p>
+            <a:endParaRPr lang="bg-BG"/>
+          </a:p>
+        </p:txBody>
       </p:sp>
       <p:sp>
         <p:nvSpPr>
@@ -8882,7 +9262,7 @@
         <p:spPr>
           <a:xfrm>
             <a:off x="2743200" y="3886200"/>
-            <a:ext cx="-685800" cy="685800"/>
+            <a:ext cx="0" cy="685800"/>
           </a:xfrm>
           <a:prstGeom prst="line">
             <a:avLst/>
@@ -8895,6 +9275,13 @@
             <a:prstDash val="solid"/>
           </a:ln>
         </p:spPr>
+        <p:txBody>
+          <a:bodyPr/>
+          <a:lstStyle/>
+          <a:p>
+            <a:endParaRPr lang="bg-BG"/>
+          </a:p>
+        </p:txBody>
       </p:sp>
       <p:sp>
         <p:nvSpPr>
@@ -8922,13 +9309,20 @@
             <a:prstDash val="solid"/>
           </a:ln>
           <a:effectLst>
-            <a:outerShdw sx="100000" sy="100000" kx="0" ky="0" algn="bl" rotWithShape="0" blurRad="12700" dist="50800" dir="2700000">
+            <a:outerShdw blurRad="12700" dist="50800" dir="2700000" algn="bl" rotWithShape="0">
               <a:srgbClr val="B8C4D1">
                 <a:alpha val="16000"/>
               </a:srgbClr>
             </a:outerShdw>
           </a:effectLst>
         </p:spPr>
+        <p:txBody>
+          <a:bodyPr/>
+          <a:lstStyle/>
+          <a:p>
+            <a:endParaRPr lang="bg-BG"/>
+          </a:p>
+        </p:txBody>
       </p:sp>
       <p:sp>
         <p:nvSpPr>
@@ -8954,6 +9348,13 @@
             <a:prstDash val="solid"/>
           </a:ln>
         </p:spPr>
+        <p:txBody>
+          <a:bodyPr/>
+          <a:lstStyle/>
+          <a:p>
+            <a:endParaRPr lang="bg-BG"/>
+          </a:p>
+        </p:txBody>
       </p:sp>
       <p:sp>
         <p:nvSpPr>
@@ -8976,7 +9377,7 @@
           <a:bodyPr wrap="square" lIns="0" tIns="0" rIns="0" bIns="0" rtlCol="0" anchor="ctr"/>
           <a:lstStyle/>
           <a:p>
-            <a:pPr indent="0" marL="0">
+            <a:pPr marL="0" indent="0">
               <a:buNone/>
             </a:pPr>
             <a:r>
@@ -9012,7 +9413,7 @@
           <a:bodyPr wrap="square" lIns="254" tIns="254" rIns="254" bIns="254" rtlCol="0" anchor="t"/>
           <a:lstStyle/>
           <a:p>
-            <a:pPr indent="0" marL="0">
+            <a:pPr marL="0" indent="0">
               <a:buNone/>
             </a:pPr>
             <a:r>
@@ -9053,13 +9454,20 @@
             <a:prstDash val="solid"/>
           </a:ln>
           <a:effectLst>
-            <a:outerShdw sx="100000" sy="100000" kx="0" ky="0" algn="bl" rotWithShape="0" blurRad="12700" dist="50800" dir="2700000">
+            <a:outerShdw blurRad="12700" dist="50800" dir="2700000" algn="bl" rotWithShape="0">
               <a:srgbClr val="B8C4D1">
                 <a:alpha val="16000"/>
               </a:srgbClr>
             </a:outerShdw>
           </a:effectLst>
         </p:spPr>
+        <p:txBody>
+          <a:bodyPr/>
+          <a:lstStyle/>
+          <a:p>
+            <a:endParaRPr lang="bg-BG"/>
+          </a:p>
+        </p:txBody>
       </p:sp>
       <p:sp>
         <p:nvSpPr>
@@ -9085,6 +9493,13 @@
             <a:prstDash val="solid"/>
           </a:ln>
         </p:spPr>
+        <p:txBody>
+          <a:bodyPr/>
+          <a:lstStyle/>
+          <a:p>
+            <a:endParaRPr lang="bg-BG"/>
+          </a:p>
+        </p:txBody>
       </p:sp>
       <p:sp>
         <p:nvSpPr>
@@ -9107,7 +9522,7 @@
           <a:bodyPr wrap="square" lIns="0" tIns="0" rIns="0" bIns="0" rtlCol="0" anchor="ctr"/>
           <a:lstStyle/>
           <a:p>
-            <a:pPr indent="0" marL="0">
+            <a:pPr marL="0" indent="0">
               <a:buNone/>
             </a:pPr>
             <a:r>
@@ -9143,7 +9558,7 @@
           <a:bodyPr wrap="square" lIns="254" tIns="254" rIns="254" bIns="254" rtlCol="0" anchor="t"/>
           <a:lstStyle/>
           <a:p>
-            <a:pPr indent="0" marL="0">
+            <a:pPr marL="0" indent="0">
               <a:buNone/>
             </a:pPr>
             <a:r>
@@ -9184,13 +9599,20 @@
             <a:prstDash val="solid"/>
           </a:ln>
           <a:effectLst>
-            <a:outerShdw sx="100000" sy="100000" kx="0" ky="0" algn="bl" rotWithShape="0" blurRad="12700" dist="50800" dir="2700000">
+            <a:outerShdw blurRad="12700" dist="50800" dir="2700000" algn="bl" rotWithShape="0">
               <a:srgbClr val="B8C4D1">
                 <a:alpha val="16000"/>
               </a:srgbClr>
             </a:outerShdw>
           </a:effectLst>
         </p:spPr>
+        <p:txBody>
+          <a:bodyPr/>
+          <a:lstStyle/>
+          <a:p>
+            <a:endParaRPr lang="bg-BG"/>
+          </a:p>
+        </p:txBody>
       </p:sp>
       <p:sp>
         <p:nvSpPr>
@@ -9216,6 +9638,13 @@
             <a:prstDash val="solid"/>
           </a:ln>
         </p:spPr>
+        <p:txBody>
+          <a:bodyPr/>
+          <a:lstStyle/>
+          <a:p>
+            <a:endParaRPr lang="bg-BG"/>
+          </a:p>
+        </p:txBody>
       </p:sp>
       <p:sp>
         <p:nvSpPr>
@@ -9238,7 +9667,7 @@
           <a:bodyPr wrap="square" lIns="0" tIns="0" rIns="0" bIns="0" rtlCol="0" anchor="ctr"/>
           <a:lstStyle/>
           <a:p>
-            <a:pPr indent="0" marL="0">
+            <a:pPr marL="0" indent="0">
               <a:buNone/>
             </a:pPr>
             <a:r>
@@ -9274,7 +9703,7 @@
           <a:bodyPr wrap="square" lIns="254" tIns="254" rIns="254" bIns="254" rtlCol="0" anchor="t"/>
           <a:lstStyle/>
           <a:p>
-            <a:pPr indent="0" marL="0">
+            <a:pPr marL="0" indent="0">
               <a:buNone/>
             </a:pPr>
             <a:r>
@@ -9313,6 +9742,13 @@
             <a:prstDash val="solid"/>
           </a:ln>
         </p:spPr>
+        <p:txBody>
+          <a:bodyPr/>
+          <a:lstStyle/>
+          <a:p>
+            <a:endParaRPr lang="bg-BG"/>
+          </a:p>
+        </p:txBody>
       </p:sp>
       <p:sp>
         <p:nvSpPr>
@@ -9335,7 +9771,7 @@
           <a:bodyPr wrap="square" lIns="0" tIns="0" rIns="0" bIns="0" rtlCol="0" anchor="ctr"/>
           <a:lstStyle/>
           <a:p>
-            <a:pPr algn="ctr" indent="0" marL="0">
+            <a:pPr marL="0" indent="0" algn="ctr">
               <a:buNone/>
             </a:pPr>
             <a:r>
@@ -9371,7 +9807,7 @@
           <a:bodyPr wrap="square" lIns="0" tIns="0" rIns="0" bIns="0" rtlCol="0" anchor="ctr"/>
           <a:lstStyle/>
           <a:p>
-            <a:pPr indent="0" marL="0">
+            <a:pPr marL="0" indent="0">
               <a:buNone/>
             </a:pPr>
             <a:r>
@@ -9407,7 +9843,7 @@
           <a:bodyPr wrap="square" lIns="0" tIns="0" rIns="0" bIns="0" rtlCol="0" anchor="ctr"/>
           <a:lstStyle/>
           <a:p>
-            <a:pPr algn="ctr" indent="0" marL="0">
+            <a:pPr marL="0" indent="0" algn="ctr">
               <a:buNone/>
             </a:pPr>
             <a:r>
@@ -9443,7 +9879,7 @@
           <a:bodyPr wrap="square" lIns="254" tIns="254" rIns="254" bIns="254" rtlCol="0" anchor="ctr"/>
           <a:lstStyle/>
           <a:p>
-            <a:pPr indent="0" marL="0">
+            <a:pPr marL="0" indent="0">
               <a:buNone/>
             </a:pPr>
             <a:r>
@@ -9457,7 +9893,7 @@
             <a:endParaRPr lang="en-US" sz="1300" dirty="0"/>
           </a:p>
           <a:p>
-            <a:pPr indent="0" marL="0">
+            <a:pPr marL="0" indent="0">
               <a:buNone/>
             </a:pPr>
             <a:r>
@@ -9493,7 +9929,7 @@
           <a:bodyPr wrap="square" lIns="0" tIns="0" rIns="0" bIns="0" rtlCol="0" anchor="ctr"/>
           <a:lstStyle/>
           <a:p>
-            <a:pPr indent="0" marL="0">
+            <a:pPr marL="0" indent="0">
               <a:buNone/>
             </a:pPr>
             <a:r>
@@ -9529,7 +9965,7 @@
           <a:bodyPr wrap="square" lIns="254" tIns="254" rIns="254" bIns="254" rtlCol="0" anchor="ctr"/>
           <a:lstStyle/>
           <a:p>
-            <a:pPr indent="0" marL="0">
+            <a:pPr marL="0" indent="0">
               <a:buNone/>
             </a:pPr>
             <a:r>
@@ -9543,7 +9979,7 @@
             <a:endParaRPr lang="en-US" sz="1350" dirty="0"/>
           </a:p>
           <a:p>
-            <a:pPr indent="0" marL="0">
+            <a:pPr marL="0" indent="0">
               <a:buNone/>
             </a:pPr>
             <a:r>
@@ -9560,7 +9996,7 @@
       </p:sp>
       <p:sp>
         <p:nvSpPr>
-          <p:cNvPr id="25" name="Slide Number Placeholder 0"/>
+          <p:cNvPr id="43" name="Slide Number Placeholder 0"/>
           <p:cNvSpPr>
             <a:spLocks noGrp="1"/>
           </p:cNvSpPr>
@@ -9578,7 +10014,7 @@
           </a:prstGeom>
           <a:extLst>
             <a:ext uri="{C572A759-6A51-4108-AA02-DFA0A04FC94B}">
-              <ma14:wrappingTextBoxFlag xmlns:ma14="http://schemas.microsoft.com/office/mac/drawingml/2011/main" val="0"/>
+              <ma14:wrappingTextBoxFlag xmlns:ma14="http://schemas.microsoft.com/office/mac/drawingml/2011/main" xmlns="" val="0"/>
             </a:ext>
           </a:extLst>
         </p:spPr>
@@ -9599,7 +10035,7 @@
           <a:p>
             <a:pPr algn="r"/>
             <a:fld id="{F7021451-1387-4CA6-816F-3879F97B5CBC}" type="slidenum">
-              <a:rPr b="0" lang="en-US"/>
+              <a:rPr lang="en-US" b="0"/>
               <a:t>8</a:t>
             </a:fld>
             <a:endParaRPr lang="en-US"/>
@@ -9652,7 +10088,7 @@
           <a:bodyPr wrap="square" lIns="0" tIns="0" rIns="0" bIns="0" rtlCol="0" anchor="ctr"/>
           <a:lstStyle/>
           <a:p>
-            <a:pPr indent="0" marL="0">
+            <a:pPr marL="0" indent="0">
               <a:buNone/>
             </a:pPr>
             <a:r>
@@ -9691,7 +10127,7 @@
           <a:bodyPr wrap="square" lIns="0" tIns="0" rIns="0" bIns="0" rtlCol="0" anchor="ctr"/>
           <a:lstStyle/>
           <a:p>
-            <a:pPr indent="0" marL="0">
+            <a:pPr marL="0" indent="0">
               <a:buNone/>
             </a:pPr>
             <a:r>
@@ -9730,7 +10166,7 @@
           <a:bodyPr wrap="square" lIns="0" tIns="0" rIns="0" bIns="0" rtlCol="0" anchor="ctr"/>
           <a:lstStyle/>
           <a:p>
-            <a:pPr indent="0" marL="0">
+            <a:pPr marL="0" indent="0">
               <a:buNone/>
             </a:pPr>
             <a:r>
@@ -9771,13 +10207,20 @@
             <a:prstDash val="solid"/>
           </a:ln>
           <a:effectLst>
-            <a:outerShdw sx="100000" sy="100000" kx="0" ky="0" algn="bl" rotWithShape="0" blurRad="12700" dist="50800" dir="2700000">
+            <a:outerShdw blurRad="12700" dist="50800" dir="2700000" algn="bl" rotWithShape="0">
               <a:srgbClr val="B8C4D1">
                 <a:alpha val="16000"/>
               </a:srgbClr>
             </a:outerShdw>
           </a:effectLst>
         </p:spPr>
+        <p:txBody>
+          <a:bodyPr/>
+          <a:lstStyle/>
+          <a:p>
+            <a:endParaRPr lang="bg-BG"/>
+          </a:p>
+        </p:txBody>
       </p:sp>
       <p:sp>
         <p:nvSpPr>
@@ -9803,6 +10246,13 @@
             <a:prstDash val="solid"/>
           </a:ln>
         </p:spPr>
+        <p:txBody>
+          <a:bodyPr/>
+          <a:lstStyle/>
+          <a:p>
+            <a:endParaRPr lang="bg-BG"/>
+          </a:p>
+        </p:txBody>
       </p:sp>
       <p:sp>
         <p:nvSpPr>
@@ -9825,7 +10275,7 @@
           <a:bodyPr wrap="square" lIns="0" tIns="0" rIns="0" bIns="0" rtlCol="0" anchor="ctr"/>
           <a:lstStyle/>
           <a:p>
-            <a:pPr indent="0" marL="0">
+            <a:pPr marL="0" indent="0">
               <a:buNone/>
             </a:pPr>
             <a:r>
@@ -9861,7 +10311,7 @@
           <a:bodyPr wrap="square" lIns="254" tIns="254" rIns="254" bIns="254" rtlCol="0" anchor="t"/>
           <a:lstStyle/>
           <a:p>
-            <a:pPr indent="0" marL="0">
+            <a:pPr marL="0" indent="0">
               <a:buNone/>
             </a:pPr>
             <a:r>
@@ -9902,13 +10352,20 @@
             <a:prstDash val="solid"/>
           </a:ln>
           <a:effectLst>
-            <a:outerShdw sx="100000" sy="100000" kx="0" ky="0" algn="bl" rotWithShape="0" blurRad="12700" dist="50800" dir="2700000">
+            <a:outerShdw blurRad="12700" dist="50800" dir="2700000" algn="bl" rotWithShape="0">
               <a:srgbClr val="B8C4D1">
                 <a:alpha val="16000"/>
               </a:srgbClr>
             </a:outerShdw>
           </a:effectLst>
         </p:spPr>
+        <p:txBody>
+          <a:bodyPr/>
+          <a:lstStyle/>
+          <a:p>
+            <a:endParaRPr lang="bg-BG"/>
+          </a:p>
+        </p:txBody>
       </p:sp>
       <p:sp>
         <p:nvSpPr>
@@ -9934,6 +10391,13 @@
             <a:prstDash val="solid"/>
           </a:ln>
         </p:spPr>
+        <p:txBody>
+          <a:bodyPr/>
+          <a:lstStyle/>
+          <a:p>
+            <a:endParaRPr lang="bg-BG"/>
+          </a:p>
+        </p:txBody>
       </p:sp>
       <p:sp>
         <p:nvSpPr>
@@ -9956,7 +10420,7 @@
           <a:bodyPr wrap="square" lIns="0" tIns="0" rIns="0" bIns="0" rtlCol="0" anchor="ctr"/>
           <a:lstStyle/>
           <a:p>
-            <a:pPr indent="0" marL="0">
+            <a:pPr marL="0" indent="0">
               <a:buNone/>
             </a:pPr>
             <a:r>
@@ -9992,7 +10456,7 @@
           <a:bodyPr wrap="square" lIns="254" tIns="254" rIns="254" bIns="254" rtlCol="0" anchor="t"/>
           <a:lstStyle/>
           <a:p>
-            <a:pPr indent="0" marL="0">
+            <a:pPr marL="0" indent="0">
               <a:buNone/>
             </a:pPr>
             <a:r>
@@ -10031,6 +10495,13 @@
             <a:tailEnd type="triangle"/>
           </a:ln>
         </p:spPr>
+        <p:txBody>
+          <a:bodyPr/>
+          <a:lstStyle/>
+          <a:p>
+            <a:endParaRPr lang="bg-BG"/>
+          </a:p>
+        </p:txBody>
       </p:sp>
       <p:sp>
         <p:nvSpPr>
@@ -10041,7 +10512,7 @@
         <p:spPr>
           <a:xfrm>
             <a:off x="3246120" y="4187952"/>
-            <a:ext cx="1463040" cy="-713232"/>
+            <a:ext cx="1463040" cy="0"/>
           </a:xfrm>
           <a:prstGeom prst="line">
             <a:avLst/>
@@ -10056,6 +10527,13 @@
             <a:tailEnd type="triangle"/>
           </a:ln>
         </p:spPr>
+        <p:txBody>
+          <a:bodyPr/>
+          <a:lstStyle/>
+          <a:p>
+            <a:endParaRPr lang="bg-BG"/>
+          </a:p>
+        </p:txBody>
       </p:sp>
       <p:sp>
         <p:nvSpPr>
@@ -10081,6 +10559,13 @@
             <a:prstDash val="solid"/>
           </a:ln>
         </p:spPr>
+        <p:txBody>
+          <a:bodyPr/>
+          <a:lstStyle/>
+          <a:p>
+            <a:endParaRPr lang="bg-BG"/>
+          </a:p>
+        </p:txBody>
       </p:sp>
       <p:sp>
         <p:nvSpPr>
@@ -10103,7 +10588,7 @@
           <a:bodyPr wrap="square" lIns="0" tIns="0" rIns="0" bIns="0" rtlCol="0" anchor="ctr"/>
           <a:lstStyle/>
           <a:p>
-            <a:pPr algn="ctr" indent="0" marL="0">
+            <a:pPr marL="0" indent="0" algn="ctr">
               <a:buNone/>
             </a:pPr>
             <a:r>
@@ -10139,7 +10624,7 @@
           <a:bodyPr wrap="square" lIns="0" tIns="0" rIns="0" bIns="0" rtlCol="0" anchor="ctr"/>
           <a:lstStyle/>
           <a:p>
-            <a:pPr algn="ctr" indent="0" marL="0">
+            <a:pPr marL="0" indent="0" algn="ctr">
               <a:buNone/>
             </a:pPr>
             <a:r>
@@ -10178,6 +10663,13 @@
             <a:tailEnd type="triangle"/>
           </a:ln>
         </p:spPr>
+        <p:txBody>
+          <a:bodyPr/>
+          <a:lstStyle/>
+          <a:p>
+            <a:endParaRPr lang="bg-BG"/>
+          </a:p>
+        </p:txBody>
       </p:sp>
       <p:sp>
         <p:nvSpPr>
@@ -10203,6 +10695,13 @@
             <a:prstDash val="solid"/>
           </a:ln>
         </p:spPr>
+        <p:txBody>
+          <a:bodyPr/>
+          <a:lstStyle/>
+          <a:p>
+            <a:endParaRPr lang="bg-BG"/>
+          </a:p>
+        </p:txBody>
       </p:sp>
       <p:sp>
         <p:nvSpPr>
@@ -10225,7 +10724,7 @@
           <a:bodyPr wrap="square" lIns="0" tIns="0" rIns="0" bIns="0" rtlCol="0" anchor="ctr"/>
           <a:lstStyle/>
           <a:p>
-            <a:pPr algn="ctr" indent="0" marL="0">
+            <a:pPr marL="0" indent="0" algn="ctr">
               <a:buNone/>
             </a:pPr>
             <a:r>
@@ -10261,7 +10760,7 @@
           <a:bodyPr wrap="square" lIns="0" tIns="0" rIns="0" bIns="0" rtlCol="0" anchor="ctr"/>
           <a:lstStyle/>
           <a:p>
-            <a:pPr algn="ctr" indent="0" marL="0">
+            <a:pPr marL="0" indent="0" algn="ctr">
               <a:buNone/>
             </a:pPr>
             <a:r>
@@ -10275,7 +10774,7 @@
             <a:endParaRPr lang="en-US" sz="1600" dirty="0"/>
           </a:p>
           <a:p>
-            <a:pPr algn="ctr" indent="0" marL="0">
+            <a:pPr marL="0" indent="0" algn="ctr">
               <a:buNone/>
             </a:pPr>
             <a:r>
@@ -10316,13 +10815,20 @@
             <a:prstDash val="solid"/>
           </a:ln>
           <a:effectLst>
-            <a:outerShdw sx="100000" sy="100000" kx="0" ky="0" algn="bl" rotWithShape="0" blurRad="12700" dist="50800" dir="2700000">
+            <a:outerShdw blurRad="12700" dist="50800" dir="2700000" algn="bl" rotWithShape="0">
               <a:srgbClr val="B8C4D1">
                 <a:alpha val="16000"/>
               </a:srgbClr>
             </a:outerShdw>
           </a:effectLst>
         </p:spPr>
+        <p:txBody>
+          <a:bodyPr/>
+          <a:lstStyle/>
+          <a:p>
+            <a:endParaRPr lang="bg-BG"/>
+          </a:p>
+        </p:txBody>
       </p:sp>
       <p:sp>
         <p:nvSpPr>
@@ -10348,6 +10854,13 @@
             <a:prstDash val="solid"/>
           </a:ln>
         </p:spPr>
+        <p:txBody>
+          <a:bodyPr/>
+          <a:lstStyle/>
+          <a:p>
+            <a:endParaRPr lang="bg-BG"/>
+          </a:p>
+        </p:txBody>
       </p:sp>
       <p:sp>
         <p:nvSpPr>
@@ -10370,7 +10883,7 @@
           <a:bodyPr wrap="square" lIns="0" tIns="0" rIns="0" bIns="0" rtlCol="0" anchor="ctr"/>
           <a:lstStyle/>
           <a:p>
-            <a:pPr indent="0" marL="0">
+            <a:pPr marL="0" indent="0">
               <a:buNone/>
             </a:pPr>
             <a:r>
@@ -10406,7 +10919,7 @@
           <a:bodyPr wrap="square" lIns="254" tIns="254" rIns="254" bIns="254" rtlCol="0" anchor="t"/>
           <a:lstStyle/>
           <a:p>
-            <a:pPr indent="0" marL="0">
+            <a:pPr marL="0" indent="0">
               <a:buNone/>
             </a:pPr>
             <a:r>
@@ -10447,13 +10960,20 @@
             <a:prstDash val="solid"/>
           </a:ln>
           <a:effectLst>
-            <a:outerShdw sx="100000" sy="100000" kx="0" ky="0" algn="bl" rotWithShape="0" blurRad="12700" dist="50800" dir="2700000">
+            <a:outerShdw blurRad="12700" dist="50800" dir="2700000" algn="bl" rotWithShape="0">
               <a:srgbClr val="B8C4D1">
                 <a:alpha val="16000"/>
               </a:srgbClr>
             </a:outerShdw>
           </a:effectLst>
         </p:spPr>
+        <p:txBody>
+          <a:bodyPr/>
+          <a:lstStyle/>
+          <a:p>
+            <a:endParaRPr lang="bg-BG"/>
+          </a:p>
+        </p:txBody>
       </p:sp>
       <p:sp>
         <p:nvSpPr>
@@ -10479,6 +10999,13 @@
             <a:prstDash val="solid"/>
           </a:ln>
         </p:spPr>
+        <p:txBody>
+          <a:bodyPr/>
+          <a:lstStyle/>
+          <a:p>
+            <a:endParaRPr lang="bg-BG"/>
+          </a:p>
+        </p:txBody>
       </p:sp>
       <p:sp>
         <p:nvSpPr>
@@ -10501,7 +11028,7 @@
           <a:bodyPr wrap="square" lIns="0" tIns="0" rIns="0" bIns="0" rtlCol="0" anchor="ctr"/>
           <a:lstStyle/>
           <a:p>
-            <a:pPr indent="0" marL="0">
+            <a:pPr marL="0" indent="0">
               <a:buNone/>
             </a:pPr>
             <a:r>
@@ -10537,7 +11064,7 @@
           <a:bodyPr wrap="square" lIns="254" tIns="254" rIns="254" bIns="254" rtlCol="0" anchor="t"/>
           <a:lstStyle/>
           <a:p>
-            <a:pPr indent="0" marL="0">
+            <a:pPr marL="0" indent="0">
               <a:buNone/>
             </a:pPr>
             <a:r>
@@ -10578,13 +11105,20 @@
             <a:prstDash val="solid"/>
           </a:ln>
           <a:effectLst>
-            <a:outerShdw sx="100000" sy="100000" kx="0" ky="0" algn="bl" rotWithShape="0" blurRad="12700" dist="50800" dir="2700000">
+            <a:outerShdw blurRad="12700" dist="50800" dir="2700000" algn="bl" rotWithShape="0">
               <a:srgbClr val="B8C4D1">
                 <a:alpha val="16000"/>
               </a:srgbClr>
             </a:outerShdw>
           </a:effectLst>
         </p:spPr>
+        <p:txBody>
+          <a:bodyPr/>
+          <a:lstStyle/>
+          <a:p>
+            <a:endParaRPr lang="bg-BG"/>
+          </a:p>
+        </p:txBody>
       </p:sp>
       <p:sp>
         <p:nvSpPr>
@@ -10610,6 +11144,13 @@
             <a:prstDash val="solid"/>
           </a:ln>
         </p:spPr>
+        <p:txBody>
+          <a:bodyPr/>
+          <a:lstStyle/>
+          <a:p>
+            <a:endParaRPr lang="bg-BG"/>
+          </a:p>
+        </p:txBody>
       </p:sp>
       <p:sp>
         <p:nvSpPr>
@@ -10632,7 +11173,7 @@
           <a:bodyPr wrap="square" lIns="0" tIns="0" rIns="0" bIns="0" rtlCol="0" anchor="ctr"/>
           <a:lstStyle/>
           <a:p>
-            <a:pPr indent="0" marL="0">
+            <a:pPr marL="0" indent="0">
               <a:buNone/>
             </a:pPr>
             <a:r>
@@ -10668,7 +11209,7 @@
           <a:bodyPr wrap="square" lIns="254" tIns="254" rIns="254" bIns="254" rtlCol="0" anchor="t"/>
           <a:lstStyle/>
           <a:p>
-            <a:pPr indent="0" marL="0">
+            <a:pPr marL="0" indent="0">
               <a:buNone/>
             </a:pPr>
             <a:r>
@@ -10685,7 +11226,7 @@
       </p:sp>
       <p:sp>
         <p:nvSpPr>
-          <p:cNvPr id="25" name="Slide Number Placeholder 0"/>
+          <p:cNvPr id="34" name="Slide Number Placeholder 0"/>
           <p:cNvSpPr>
             <a:spLocks noGrp="1"/>
           </p:cNvSpPr>
@@ -10703,7 +11244,7 @@
           </a:prstGeom>
           <a:extLst>
             <a:ext uri="{C572A759-6A51-4108-AA02-DFA0A04FC94B}">
-              <ma14:wrappingTextBoxFlag xmlns:ma14="http://schemas.microsoft.com/office/mac/drawingml/2011/main" val="0"/>
+              <ma14:wrappingTextBoxFlag xmlns:ma14="http://schemas.microsoft.com/office/mac/drawingml/2011/main" xmlns="" val="0"/>
             </a:ext>
           </a:extLst>
         </p:spPr>
@@ -10724,7 +11265,7 @@
           <a:p>
             <a:pPr algn="r"/>
             <a:fld id="{F7021451-1387-4CA6-816F-3879F97B5CBC}" type="slidenum">
-              <a:rPr b="0" lang="en-US"/>
+              <a:rPr lang="en-US" b="0"/>
               <a:t>9</a:t>
             </a:fld>
             <a:endParaRPr lang="en-US"/>
@@ -11032,4 +11573,319 @@
     </a:ext>
   </a:extLst>
 </a:theme>
+</file>
+
+<file path=ppt/theme/theme2.xml><?xml version="1.0" encoding="utf-8"?>
+<a:theme xmlns:a="http://schemas.openxmlformats.org/drawingml/2006/main" name="Office Theme">
+  <a:themeElements>
+    <a:clrScheme name="Office">
+      <a:dk1>
+        <a:sysClr val="windowText" lastClr="000000"/>
+      </a:dk1>
+      <a:lt1>
+        <a:sysClr val="window" lastClr="FFFFFF"/>
+      </a:lt1>
+      <a:dk2>
+        <a:srgbClr val="0E2841"/>
+      </a:dk2>
+      <a:lt2>
+        <a:srgbClr val="E8E8E8"/>
+      </a:lt2>
+      <a:accent1>
+        <a:srgbClr val="156082"/>
+      </a:accent1>
+      <a:accent2>
+        <a:srgbClr val="E97132"/>
+      </a:accent2>
+      <a:accent3>
+        <a:srgbClr val="196B24"/>
+      </a:accent3>
+      <a:accent4>
+        <a:srgbClr val="0F9ED5"/>
+      </a:accent4>
+      <a:accent5>
+        <a:srgbClr val="A02B93"/>
+      </a:accent5>
+      <a:accent6>
+        <a:srgbClr val="4EA72E"/>
+      </a:accent6>
+      <a:hlink>
+        <a:srgbClr val="467886"/>
+      </a:hlink>
+      <a:folHlink>
+        <a:srgbClr val="96607D"/>
+      </a:folHlink>
+    </a:clrScheme>
+    <a:fontScheme name="Office">
+      <a:majorFont>
+        <a:latin typeface="Aptos Display" panose="02110004020202020204"/>
+        <a:ea typeface=""/>
+        <a:cs typeface=""/>
+        <a:font script="Jpan" typeface="游ゴシック Light"/>
+        <a:font script="Hang" typeface="맑은 고딕"/>
+        <a:font script="Hans" typeface="等线 Light"/>
+        <a:font script="Hant" typeface="新細明體"/>
+        <a:font script="Arab" typeface="Times New Roman"/>
+        <a:font script="Hebr" typeface="Times New Roman"/>
+        <a:font script="Thai" typeface="Angsana New"/>
+        <a:font script="Ethi" typeface="Nyala"/>
+        <a:font script="Beng" typeface="Vrinda"/>
+        <a:font script="Gujr" typeface="Shruti"/>
+        <a:font script="Khmr" typeface="MoolBoran"/>
+        <a:font script="Knda" typeface="Tunga"/>
+        <a:font script="Guru" typeface="Raavi"/>
+        <a:font script="Cans" typeface="Euphemia"/>
+        <a:font script="Cher" typeface="Plantagenet Cherokee"/>
+        <a:font script="Yiii" typeface="Microsoft Yi Baiti"/>
+        <a:font script="Tibt" typeface="Microsoft Himalaya"/>
+        <a:font script="Thaa" typeface="MV Boli"/>
+        <a:font script="Deva" typeface="Mangal"/>
+        <a:font script="Telu" typeface="Gautami"/>
+        <a:font script="Taml" typeface="Latha"/>
+        <a:font script="Syrc" typeface="Estrangelo Edessa"/>
+        <a:font script="Orya" typeface="Kalinga"/>
+        <a:font script="Mlym" typeface="Kartika"/>
+        <a:font script="Laoo" typeface="DokChampa"/>
+        <a:font script="Sinh" typeface="Iskoola Pota"/>
+        <a:font script="Mong" typeface="Mongolian Baiti"/>
+        <a:font script="Viet" typeface="Times New Roman"/>
+        <a:font script="Uigh" typeface="Microsoft Uighur"/>
+        <a:font script="Geor" typeface="Sylfaen"/>
+        <a:font script="Armn" typeface="Arial"/>
+        <a:font script="Bugi" typeface="Leelawadee UI"/>
+        <a:font script="Bopo" typeface="Microsoft JhengHei"/>
+        <a:font script="Java" typeface="Javanese Text"/>
+        <a:font script="Lisu" typeface="Segoe UI"/>
+        <a:font script="Mymr" typeface="Myanmar Text"/>
+        <a:font script="Nkoo" typeface="Ebrima"/>
+        <a:font script="Olck" typeface="Nirmala UI"/>
+        <a:font script="Osma" typeface="Ebrima"/>
+        <a:font script="Phag" typeface="Phagspa"/>
+        <a:font script="Syrn" typeface="Estrangelo Edessa"/>
+        <a:font script="Syrj" typeface="Estrangelo Edessa"/>
+        <a:font script="Syre" typeface="Estrangelo Edessa"/>
+        <a:font script="Sora" typeface="Nirmala UI"/>
+        <a:font script="Tale" typeface="Microsoft Tai Le"/>
+        <a:font script="Talu" typeface="Microsoft New Tai Lue"/>
+        <a:font script="Tfng" typeface="Ebrima"/>
+      </a:majorFont>
+      <a:minorFont>
+        <a:latin typeface="Aptos" panose="02110004020202020204"/>
+        <a:ea typeface=""/>
+        <a:cs typeface=""/>
+        <a:font script="Jpan" typeface="游ゴシック"/>
+        <a:font script="Hang" typeface="맑은 고딕"/>
+        <a:font script="Hans" typeface="等线"/>
+        <a:font script="Hant" typeface="新細明體"/>
+        <a:font script="Arab" typeface="Arial"/>
+        <a:font script="Hebr" typeface="Arial"/>
+        <a:font script="Thai" typeface="Cordia New"/>
+        <a:font script="Ethi" typeface="Nyala"/>
+        <a:font script="Beng" typeface="Vrinda"/>
+        <a:font script="Gujr" typeface="Shruti"/>
+        <a:font script="Khmr" typeface="DaunPenh"/>
+        <a:font script="Knda" typeface="Tunga"/>
+        <a:font script="Guru" typeface="Raavi"/>
+        <a:font script="Cans" typeface="Euphemia"/>
+        <a:font script="Cher" typeface="Plantagenet Cherokee"/>
+        <a:font script="Yiii" typeface="Microsoft Yi Baiti"/>
+        <a:font script="Tibt" typeface="Microsoft Himalaya"/>
+        <a:font script="Thaa" typeface="MV Boli"/>
+        <a:font script="Deva" typeface="Mangal"/>
+        <a:font script="Telu" typeface="Gautami"/>
+        <a:font script="Taml" typeface="Latha"/>
+        <a:font script="Syrc" typeface="Estrangelo Edessa"/>
+        <a:font script="Orya" typeface="Kalinga"/>
+        <a:font script="Mlym" typeface="Kartika"/>
+        <a:font script="Laoo" typeface="DokChampa"/>
+        <a:font script="Sinh" typeface="Iskoola Pota"/>
+        <a:font script="Mong" typeface="Mongolian Baiti"/>
+        <a:font script="Viet" typeface="Arial"/>
+        <a:font script="Uigh" typeface="Microsoft Uighur"/>
+        <a:font script="Geor" typeface="Sylfaen"/>
+        <a:font script="Armn" typeface="Arial"/>
+        <a:font script="Bugi" typeface="Leelawadee UI"/>
+        <a:font script="Bopo" typeface="Microsoft JhengHei"/>
+        <a:font script="Java" typeface="Javanese Text"/>
+        <a:font script="Lisu" typeface="Segoe UI"/>
+        <a:font script="Mymr" typeface="Myanmar Text"/>
+        <a:font script="Nkoo" typeface="Ebrima"/>
+        <a:font script="Olck" typeface="Nirmala UI"/>
+        <a:font script="Osma" typeface="Ebrima"/>
+        <a:font script="Phag" typeface="Phagspa"/>
+        <a:font script="Syrn" typeface="Estrangelo Edessa"/>
+        <a:font script="Syrj" typeface="Estrangelo Edessa"/>
+        <a:font script="Syre" typeface="Estrangelo Edessa"/>
+        <a:font script="Sora" typeface="Nirmala UI"/>
+        <a:font script="Tale" typeface="Microsoft Tai Le"/>
+        <a:font script="Talu" typeface="Microsoft New Tai Lue"/>
+        <a:font script="Tfng" typeface="Ebrima"/>
+      </a:minorFont>
+    </a:fontScheme>
+    <a:fmtScheme name="Office">
+      <a:fillStyleLst>
+        <a:solidFill>
+          <a:schemeClr val="phClr"/>
+        </a:solidFill>
+        <a:gradFill rotWithShape="1">
+          <a:gsLst>
+            <a:gs pos="0">
+              <a:schemeClr val="phClr">
+                <a:lumMod val="110000"/>
+                <a:satMod val="105000"/>
+                <a:tint val="67000"/>
+              </a:schemeClr>
+            </a:gs>
+            <a:gs pos="50000">
+              <a:schemeClr val="phClr">
+                <a:lumMod val="105000"/>
+                <a:satMod val="103000"/>
+                <a:tint val="73000"/>
+              </a:schemeClr>
+            </a:gs>
+            <a:gs pos="100000">
+              <a:schemeClr val="phClr">
+                <a:lumMod val="105000"/>
+                <a:satMod val="109000"/>
+                <a:tint val="81000"/>
+              </a:schemeClr>
+            </a:gs>
+          </a:gsLst>
+          <a:lin ang="5400000" scaled="0"/>
+        </a:gradFill>
+        <a:gradFill rotWithShape="1">
+          <a:gsLst>
+            <a:gs pos="0">
+              <a:schemeClr val="phClr">
+                <a:satMod val="103000"/>
+                <a:lumMod val="102000"/>
+                <a:tint val="94000"/>
+              </a:schemeClr>
+            </a:gs>
+            <a:gs pos="50000">
+              <a:schemeClr val="phClr">
+                <a:satMod val="110000"/>
+                <a:lumMod val="100000"/>
+                <a:shade val="100000"/>
+              </a:schemeClr>
+            </a:gs>
+            <a:gs pos="100000">
+              <a:schemeClr val="phClr">
+                <a:lumMod val="99000"/>
+                <a:satMod val="120000"/>
+                <a:shade val="78000"/>
+              </a:schemeClr>
+            </a:gs>
+          </a:gsLst>
+          <a:lin ang="5400000" scaled="0"/>
+        </a:gradFill>
+      </a:fillStyleLst>
+      <a:lnStyleLst>
+        <a:ln w="12700" cap="flat" cmpd="sng" algn="ctr">
+          <a:solidFill>
+            <a:schemeClr val="phClr"/>
+          </a:solidFill>
+          <a:prstDash val="solid"/>
+          <a:miter lim="800000"/>
+        </a:ln>
+        <a:ln w="19050" cap="flat" cmpd="sng" algn="ctr">
+          <a:solidFill>
+            <a:schemeClr val="phClr"/>
+          </a:solidFill>
+          <a:prstDash val="solid"/>
+          <a:miter lim="800000"/>
+        </a:ln>
+        <a:ln w="25400" cap="flat" cmpd="sng" algn="ctr">
+          <a:solidFill>
+            <a:schemeClr val="phClr"/>
+          </a:solidFill>
+          <a:prstDash val="solid"/>
+          <a:miter lim="800000"/>
+        </a:ln>
+      </a:lnStyleLst>
+      <a:effectStyleLst>
+        <a:effectStyle>
+          <a:effectLst/>
+        </a:effectStyle>
+        <a:effectStyle>
+          <a:effectLst/>
+        </a:effectStyle>
+        <a:effectStyle>
+          <a:effectLst>
+            <a:outerShdw blurRad="57150" dist="19050" dir="5400000" algn="ctr" rotWithShape="0">
+              <a:srgbClr val="000000">
+                <a:alpha val="63000"/>
+              </a:srgbClr>
+            </a:outerShdw>
+          </a:effectLst>
+        </a:effectStyle>
+      </a:effectStyleLst>
+      <a:bgFillStyleLst>
+        <a:solidFill>
+          <a:schemeClr val="phClr"/>
+        </a:solidFill>
+        <a:solidFill>
+          <a:schemeClr val="phClr">
+            <a:tint val="95000"/>
+            <a:satMod val="170000"/>
+          </a:schemeClr>
+        </a:solidFill>
+        <a:gradFill rotWithShape="1">
+          <a:gsLst>
+            <a:gs pos="0">
+              <a:schemeClr val="phClr">
+                <a:tint val="93000"/>
+                <a:satMod val="150000"/>
+                <a:shade val="98000"/>
+                <a:lumMod val="102000"/>
+              </a:schemeClr>
+            </a:gs>
+            <a:gs pos="50000">
+              <a:schemeClr val="phClr">
+                <a:tint val="98000"/>
+                <a:satMod val="130000"/>
+                <a:shade val="90000"/>
+                <a:lumMod val="103000"/>
+              </a:schemeClr>
+            </a:gs>
+            <a:gs pos="100000">
+              <a:schemeClr val="phClr">
+                <a:shade val="63000"/>
+                <a:satMod val="120000"/>
+              </a:schemeClr>
+            </a:gs>
+          </a:gsLst>
+          <a:lin ang="5400000" scaled="0"/>
+        </a:gradFill>
+      </a:bgFillStyleLst>
+    </a:fmtScheme>
+  </a:themeElements>
+  <a:objectDefaults>
+    <a:lnDef>
+      <a:spPr/>
+      <a:bodyPr/>
+      <a:lstStyle/>
+      <a:style>
+        <a:lnRef idx="2">
+          <a:schemeClr val="accent1"/>
+        </a:lnRef>
+        <a:fillRef idx="0">
+          <a:schemeClr val="accent1"/>
+        </a:fillRef>
+        <a:effectRef idx="1">
+          <a:schemeClr val="accent1"/>
+        </a:effectRef>
+        <a:fontRef idx="minor">
+          <a:schemeClr val="tx1"/>
+        </a:fontRef>
+      </a:style>
+    </a:lnDef>
+  </a:objectDefaults>
+  <a:extraClrSchemeLst/>
+  <a:extLst>
+    <a:ext uri="{05A4C25C-085E-4340-85A3-A5531E510DB2}">
+      <thm15:themeFamily xmlns:thm15="http://schemas.microsoft.com/office/thememl/2012/main" name="Office Theme" id="{2E142A2C-CD16-42D6-873A-C26D2A0506FA}" vid="{1BDDFF52-6CD6-40A5-AB3C-68EB2F1E4D0A}"/>
+    </a:ext>
+  </a:extLst>
+</a:theme>
 </file>
</xml_diff>